<commit_message>
docs(sharing): add architecture split page (server/client/daemon) to v3 deck
</commit_message>
<xml_diff>
--- a/多智能体协同技术分享/从一个人爽到一群人接住：TabTin 与 AI 协作难题 v3.pptx
+++ b/多智能体协同技术分享/从一个人爽到一群人接住：TabTin 与 AI 协作难题 v3.pptx
@@ -31,6 +31,7 @@
     <p:sldId id="275" r:id="rId28"/>
     <p:sldId id="276" r:id="rId29"/>
     <p:sldId id="277" r:id="rId30"/>
+    <p:sldId id="278" r:id="rId31"/>
   </p:sldIdLst>
   <p:sldSz cx="12192000" cy="6858000"/>
   <p:notesSz cx="6858000" cy="9144000"/>
@@ -3016,7 +3017,7 @@
                   <a:srgbClr val="000000"/>
                 </a:solidFill>
               </a:rPr>
-              <a:t>这个项目不是套壳。它开放的是真实产品代码：Electron 桌面端、移动端、服务端、Agent Runtime、实时协作、管理后台，AGPL 协议，可以自己部署。</a:t>
+              <a:t>这页回答一个问题：到底是谁在动你的电脑。整个系统分三层。</a:t>
             </a:r>
           </a:p>
           <a:p>
@@ -3031,7 +3032,7 @@
                   <a:srgbClr val="000000"/>
                 </a:solidFill>
               </a:rPr>
-              <a:t>我读源码时注意到三个架构决策，比功能列表更能说明它想做什么。</a:t>
+              <a:t>左边是服务端和多端壳。身份、任务、资产、RAG、记忆、权限这些真源都在服务端 tabtin_django；Electron、网页、手机只是你操作的界面。</a:t>
             </a:r>
           </a:p>
           <a:p>
@@ -3046,7 +3047,7 @@
                   <a:srgbClr val="000000"/>
                 </a:solidFill>
               </a:rPr>
-              <a:t>第一，Agent 和 Device 是解耦的——Agent 表示"谁参与"，Device 表示"在哪执行"。同一个 Agent 可以在不同电脑上跑，你手机上发起的任务在桌面 Daemon 上执行。</a:t>
+              <a:t>右边是本地 daemon，这是关键。它跑在你这台真实机器上（也可以是远程服务器），真正开终端、开浏览器、在授权目录里读写文件、跑 Python、连 MCP、加载技能的，都是它。安全边界也在它这一侧：审批三档和每次 run 的预算，决定它在这台机器上能干多宽。它和服务端之间走一条长连接收任务、回传结果。</a:t>
             </a:r>
           </a:p>
           <a:p>
@@ -3061,37 +3062,7 @@
                   <a:srgbClr val="000000"/>
                 </a:solidFill>
               </a:rPr>
-              <a:t>第二，交接不等于共享目录。你的 Workspace 是私有的，任务交接时只带引用材料和上下文，不会把你的整个本地目录甩给同事。</a:t>
-            </a:r>
-          </a:p>
-          <a:p>
-            <a:pPr algn="l" marL="0" indent="0">
-              <a:lnSpc>
-                <a:spcPct val="100000"/>
-              </a:lnSpc>
-            </a:pPr>
-            <a:r>
-              <a:rPr lang="en-US" b="false" i="false" strike="noStrike" u="none" sz="1400">
-                <a:solidFill>
-                  <a:srgbClr val="000000"/>
-                </a:solidFill>
-              </a:rPr>
-              <a:t>第三，它的检查点叫 Shadow Git——在用户项目目录外面维护一个隐藏仓库，通过 core.worktree 指向你的项目，不污染你自己的 .git。这是"工作可交接"在工程上的具体落地。</a:t>
-            </a:r>
-          </a:p>
-          <a:p>
-            <a:pPr algn="l" marL="0" indent="0">
-              <a:lnSpc>
-                <a:spcPct val="100000"/>
-              </a:lnSpc>
-            </a:pPr>
-            <a:r>
-              <a:rPr lang="en-US" b="false" i="false" strike="noStrike" u="none" sz="1400">
-                <a:solidFill>
-                  <a:srgbClr val="000000"/>
-                </a:solidFill>
-              </a:rPr>
-              <a:t>当然它现在还是 Public Preview，成熟度参差不齐，这点要有预期。</a:t>
+              <a:t>所以身份和执行是分离的：Agent 定义在服务端，你在手机上发起任务，服务端把指令路由到你台式机的 daemon 去执行。这就是为什么它能"手机发起、桌面执行"，也能把 daemon 丢到一台服务器上无人值守。</a:t>
             </a:r>
           </a:p>
         </p:txBody>
@@ -3316,7 +3287,7 @@
                   <a:srgbClr val="000000"/>
                 </a:solidFill>
               </a:rPr>
-              <a:t>这一页直接对比。</a:t>
+              <a:t>这个项目不是套壳。它开放的是真实产品代码：Electron 桌面端、移动端、服务端、Agent Runtime、实时协作、管理后台，AGPL 协议，可以自己部署。</a:t>
             </a:r>
           </a:p>
           <a:p>
@@ -3331,7 +3302,7 @@
                   <a:srgbClr val="000000"/>
                 </a:solidFill>
               </a:rPr>
-              <a:t>Codex 和 Claude Code 的设计假设从头到尾就是单用户。Codex 是"派发后走开"，所以用内核级沙箱做硬隔离；Claude Code 是"人在终端前盯着"，所以用 hooks 和 /rewind 做软边界。</a:t>
+              <a:t>我读源码时注意到三个架构决策，比功能列表更能说明它想做什么。</a:t>
             </a:r>
           </a:p>
           <a:p>
@@ -3346,7 +3317,7 @@
                   <a:srgbClr val="000000"/>
                 </a:solidFill>
               </a:rPr>
-              <a:t>TabTin 不一样的地方在最后两行：多人协作和工作交接。它假设一个团队，人和 Agent 一起干活。CRDT 让人和 Agent 同时编辑同一份文档；交接时冻结上下文带引用材料，不是把整个目录甩给同事。</a:t>
+              <a:t>第一，Agent 和 Device 是解耦的——Agent 表示"谁参与"，Device 表示"在哪执行"。同一个 Agent 可以在不同电脑上跑，你手机上发起的任务在桌面 Daemon 上执行。</a:t>
             </a:r>
           </a:p>
           <a:p>
@@ -3361,7 +3332,37 @@
                   <a:srgbClr val="000000"/>
                 </a:solidFill>
               </a:rPr>
-              <a:t>但它不是全赢——coding 深度不如那两个，沙箱也不是内核级。它的定位是：Codex 和 Claude Code 把"一个人跟 AI 干活"磨到了极致，TabTin 站在右边那层空白上，解决"一个人干完了怎么让下一个人接得住"。</a:t>
+              <a:t>第二，交接不等于共享目录。你的 Workspace 是私有的，任务交接时只带引用材料和上下文，不会把你的整个本地目录甩给同事。</a:t>
+            </a:r>
+          </a:p>
+          <a:p>
+            <a:pPr algn="l" marL="0" indent="0">
+              <a:lnSpc>
+                <a:spcPct val="100000"/>
+              </a:lnSpc>
+            </a:pPr>
+            <a:r>
+              <a:rPr lang="en-US" b="false" i="false" strike="noStrike" u="none" sz="1400">
+                <a:solidFill>
+                  <a:srgbClr val="000000"/>
+                </a:solidFill>
+              </a:rPr>
+              <a:t>第三，它的检查点叫 Shadow Git——在用户项目目录外面维护一个隐藏仓库，通过 core.worktree 指向你的项目，不污染你自己的 .git。这是"工作可交接"在工程上的具体落地。</a:t>
+            </a:r>
+          </a:p>
+          <a:p>
+            <a:pPr algn="l" marL="0" indent="0">
+              <a:lnSpc>
+                <a:spcPct val="100000"/>
+              </a:lnSpc>
+            </a:pPr>
+            <a:r>
+              <a:rPr lang="en-US" b="false" i="false" strike="noStrike" u="none" sz="1400">
+                <a:solidFill>
+                  <a:srgbClr val="000000"/>
+                </a:solidFill>
+              </a:rPr>
+              <a:t>当然它现在还是 Public Preview，成熟度参差不齐，这点要有预期。</a:t>
             </a:r>
           </a:p>
         </p:txBody>
@@ -3841,7 +3842,7 @@
                   <a:srgbClr val="000000"/>
                 </a:solidFill>
               </a:rPr>
-              <a:t>把今天讲的两条路放在一起看。</a:t>
+              <a:t>这一页直接对比。</a:t>
             </a:r>
           </a:p>
           <a:p>
@@ -3856,7 +3857,7 @@
                   <a:srgbClr val="000000"/>
                 </a:solidFill>
               </a:rPr>
-              <a:t>左边多智能体协同，保护的是 agent 之间的独立视角，不让它在层级汇报中被压平。右边 TabTin，保护的是人之间的工作上下文，不让它在交接中被丢掉。</a:t>
+              <a:t>Codex 和 Claude Code 的设计假设从头到尾就是单用户。Codex 是"派发后走开"，所以用内核级沙箱做硬隔离；Claude Code 是"人在终端前盯着"，所以用 hooks 和 /rewind 做软边界。</a:t>
             </a:r>
           </a:p>
           <a:p>
@@ -3871,7 +3872,7 @@
                   <a:srgbClr val="000000"/>
                 </a:solidFill>
               </a:rPr>
-              <a:t>方向不同，但你看下面这行——它们填的是同一道沟：信息从一个工作主体传到另一个工作主体时，别在"汇报/交接"这一步被压成有损摘要。</a:t>
+              <a:t>TabTin 不一样的地方在最后两行：多人协作和工作交接。它假设一个团队，人和 Agent 一起干活。CRDT 让人和 Agent 同时编辑同一份文档；交接时冻结上下文带引用材料，不是把整个目录甩给同事。</a:t>
             </a:r>
           </a:p>
           <a:p>
@@ -3886,7 +3887,7 @@
                   <a:srgbClr val="000000"/>
                 </a:solidFill>
               </a:rPr>
-              <a:t>这就是为什么我说 TabTin 是个影子——它背后是整个 AI 协作领域正在面对的同一个问题。</a:t>
+              <a:t>但它不是全赢——coding 深度不如那两个，沙箱也不是内核级。它的定位是：Codex 和 Claude Code 把"一个人跟 AI 干活"磨到了极致，TabTin 站在右边那层空白上，解决"一个人干完了怎么让下一个人接得住"。</a:t>
             </a:r>
           </a:p>
         </p:txBody>
@@ -4111,7 +4112,7 @@
                   <a:srgbClr val="000000"/>
                 </a:solidFill>
               </a:rPr>
-              <a:t>最后不讲大道理，给一个明天就能试的动作。</a:t>
+              <a:t>把今天讲的两条路放在一起看。</a:t>
             </a:r>
           </a:p>
           <a:p>
@@ -4126,7 +4127,7 @@
                   <a:srgbClr val="000000"/>
                 </a:solidFill>
               </a:rPr>
-              <a:t>下次你用 AI 做完一个东西，别只把最终文件丢给同事。多做一步：把"我当时为什么这么判断、参考了哪几个资料、否掉了哪个方案"一起交出去。哪怕就是在文档开头写三行字。</a:t>
+              <a:t>左边多智能体协同，保护的是 agent 之间的独立视角，不让它在层级汇报中被压平。右边 TabTin，保护的是人之间的工作上下文，不让它在交接中被丢掉。</a:t>
             </a:r>
           </a:p>
           <a:p>
@@ -4141,7 +4142,7 @@
                   <a:srgbClr val="000000"/>
                 </a:solidFill>
               </a:rPr>
-              <a:t>这就是 TabTin 在工程上自动化的事——冻结上下文、带上引用材料。但不用等平台，今天手动就能开始。</a:t>
+              <a:t>方向不同，但你看下面这行——它们填的是同一道沟：信息从一个工作主体传到另一个工作主体时，别在"汇报/交接"这一步被压成有损摘要。</a:t>
             </a:r>
           </a:p>
           <a:p>
@@ -4156,7 +4157,7 @@
                   <a:srgbClr val="000000"/>
                 </a:solidFill>
               </a:rPr>
-              <a:t>多智能体也好，协作平台也好，核心就一句话：让工作能被下一个人接得住。</a:t>
+              <a:t>这就是为什么我说 TabTin 是个影子——它背后是整个 AI 协作领域正在面对的同一个问题。</a:t>
             </a:r>
           </a:p>
         </p:txBody>
@@ -4233,6 +4234,276 @@
 </file>
 
 <file path=ppt/notesSlides/notesSlide22.xml><?xml version="1.0" encoding="utf-8"?>
+<p:notes xmlns:p="http://schemas.openxmlformats.org/presentationml/2006/main" xmlns:a="http://schemas.openxmlformats.org/drawingml/2006/main">
+  <p:cSld>
+    <p:spTree xmlns:r="http://schemas.openxmlformats.org/officeDocument/2006/relationships">
+      <p:nvGrpSpPr>
+        <p:cNvPr id="1" name=""/>
+        <p:cNvGrpSpPr/>
+        <p:nvPr/>
+      </p:nvGrpSpPr>
+      <p:grpSpPr>
+        <a:xfrm>
+          <a:off x="0" y="0"/>
+          <a:ext cx="0" cy="0"/>
+          <a:chOff x="0" y="0"/>
+          <a:chExt cx="0" cy="0"/>
+        </a:xfrm>
+      </p:grpSpPr>
+      <p:sp>
+        <p:nvSpPr>
+          <p:cNvPr id="2" name="Header Placeholder 1"/>
+          <p:cNvSpPr>
+            <a:spLocks noGrp="1"/>
+          </p:cNvSpPr>
+          <p:nvPr>
+            <p:ph type="hdr" sz="quarter"/>
+          </p:nvPr>
+        </p:nvSpPr>
+        <p:spPr>
+          <a:xfrm>
+            <a:off x="0" y="0"/>
+            <a:ext cx="3962400" cy="342900"/>
+          </a:xfrm>
+          <a:prstGeom prst="rect">
+            <a:avLst/>
+          </a:prstGeom>
+        </p:spPr>
+        <p:txBody>
+          <a:bodyPr vert="horz" lIns="91440" tIns="45720" rIns="91440" bIns="45720" rtlCol="0"/>
+          <a:lstStyle>
+            <a:lvl1pPr algn="l">
+              <a:defRPr sz="1200"/>
+            </a:lvl1pPr>
+          </a:lstStyle>
+          <a:p/>
+        </p:txBody>
+      </p:sp>
+      <p:sp>
+        <p:nvSpPr>
+          <p:cNvPr id="3" name="Date Placeholder 2"/>
+          <p:cNvSpPr>
+            <a:spLocks noGrp="1"/>
+          </p:cNvSpPr>
+          <p:nvPr>
+            <p:ph type="dt" idx="1"/>
+          </p:nvPr>
+        </p:nvSpPr>
+        <p:spPr>
+          <a:xfrm>
+            <a:off x="5180013" y="0"/>
+            <a:ext cx="3962400" cy="342900"/>
+          </a:xfrm>
+          <a:prstGeom prst="rect">
+            <a:avLst/>
+          </a:prstGeom>
+        </p:spPr>
+        <p:txBody>
+          <a:bodyPr vert="horz" lIns="91440" tIns="45720" rIns="91440" bIns="45720" rtlCol="0"/>
+          <a:lstStyle>
+            <a:lvl1pPr algn="r">
+              <a:defRPr sz="1200"/>
+            </a:lvl1pPr>
+          </a:lstStyle>
+          <a:p>
+            <a:r id="{B7268E1E-0E44-426D-905E-8AD9B19D2182}" type="datetimeFigureOut">
+              <a:rPr lang="cs-CZ" smtClean="0"/>
+              <a:t>1.7.2013</a:t>
+            </a:r>
+          </a:p>
+        </p:txBody>
+      </p:sp>
+      <p:sp>
+        <p:nvSpPr>
+          <p:cNvPr id="4" name="Slide Image Placeholder 3"/>
+          <p:cNvSpPr>
+            <a:spLocks noGrp="1" noRot="1" noChangeAspect="1"/>
+          </p:cNvSpPr>
+          <p:nvPr>
+            <p:ph type="sldImg" idx="2"/>
+          </p:nvPr>
+        </p:nvSpPr>
+        <p:spPr>
+          <a:xfrm>
+            <a:off x="2857500" y="512763"/>
+            <a:ext cx="3429000" cy="2566987"/>
+          </a:xfrm>
+          <a:prstGeom prst="rect">
+            <a:avLst/>
+          </a:prstGeom>
+          <a:noFill/>
+          <a:ln w="12700">
+            <a:solidFill>
+              <a:prstClr val="black"/>
+            </a:solidFill>
+          </a:ln>
+        </p:spPr>
+        <p:txBody>
+          <a:bodyPr vert="horz" lIns="91440" tIns="45720" rIns="91440" bIns="45720" rtlCol="0" anchor="ctr"/>
+          <a:lstStyle/>
+          <a:p/>
+        </p:txBody>
+      </p:sp>
+      <p:sp>
+        <p:nvSpPr>
+          <p:cNvPr id="5" name="Notes Placeholder 4"/>
+          <p:cNvSpPr>
+            <a:spLocks noGrp="1"/>
+          </p:cNvSpPr>
+          <p:nvPr>
+            <p:ph type="body" sz="quarter" idx="3"/>
+          </p:nvPr>
+        </p:nvSpPr>
+        <p:spPr>
+          <a:xfrm>
+            <a:off x="914400" y="3251200"/>
+            <a:ext cx="7315200" cy="3081338"/>
+          </a:xfrm>
+          <a:prstGeom prst="rect">
+            <a:avLst/>
+          </a:prstGeom>
+        </p:spPr>
+        <p:txBody>
+          <a:bodyPr vert="horz" lIns="91440" tIns="45720" rIns="91440" bIns="45720" rtlCol="0" anchor="ctr"/>
+          <a:lstStyle>
+            <a:lvl1pPr algn="l">
+              <a:defRPr sz="1400" b="false" i="false" u="none" strike="noStrike"/>
+            </a:lvl1pPr>
+          </a:lstStyle>
+          <a:p>
+            <a:pPr algn="l" marL="0" indent="0">
+              <a:lnSpc>
+                <a:spcPct val="100000"/>
+              </a:lnSpc>
+            </a:pPr>
+            <a:r>
+              <a:rPr lang="en-US" b="false" i="false" strike="noStrike" u="none" sz="1400">
+                <a:solidFill>
+                  <a:srgbClr val="000000"/>
+                </a:solidFill>
+              </a:rPr>
+              <a:t>最后不讲大道理，给一个明天就能试的动作。</a:t>
+            </a:r>
+          </a:p>
+          <a:p>
+            <a:pPr algn="l" marL="0" indent="0">
+              <a:lnSpc>
+                <a:spcPct val="100000"/>
+              </a:lnSpc>
+            </a:pPr>
+            <a:r>
+              <a:rPr lang="en-US" b="false" i="false" strike="noStrike" u="none" sz="1400">
+                <a:solidFill>
+                  <a:srgbClr val="000000"/>
+                </a:solidFill>
+              </a:rPr>
+              <a:t>下次你用 AI 做完一个东西，别只把最终文件丢给同事。多做一步：把"我当时为什么这么判断、参考了哪几个资料、否掉了哪个方案"一起交出去。哪怕就是在文档开头写三行字。</a:t>
+            </a:r>
+          </a:p>
+          <a:p>
+            <a:pPr algn="l" marL="0" indent="0">
+              <a:lnSpc>
+                <a:spcPct val="100000"/>
+              </a:lnSpc>
+            </a:pPr>
+            <a:r>
+              <a:rPr lang="en-US" b="false" i="false" strike="noStrike" u="none" sz="1400">
+                <a:solidFill>
+                  <a:srgbClr val="000000"/>
+                </a:solidFill>
+              </a:rPr>
+              <a:t>这就是 TabTin 在工程上自动化的事——冻结上下文、带上引用材料。但不用等平台，今天手动就能开始。</a:t>
+            </a:r>
+          </a:p>
+          <a:p>
+            <a:pPr algn="l" marL="0" indent="0">
+              <a:lnSpc>
+                <a:spcPct val="100000"/>
+              </a:lnSpc>
+            </a:pPr>
+            <a:r>
+              <a:rPr lang="en-US" b="false" i="false" strike="noStrike" u="none" sz="1400">
+                <a:solidFill>
+                  <a:srgbClr val="000000"/>
+                </a:solidFill>
+              </a:rPr>
+              <a:t>多智能体也好，协作平台也好，核心就一句话：让工作能被下一个人接得住。</a:t>
+            </a:r>
+          </a:p>
+        </p:txBody>
+      </p:sp>
+      <p:sp>
+        <p:nvSpPr>
+          <p:cNvPr id="6" name="Footer Placeholder 5"/>
+          <p:cNvSpPr>
+            <a:spLocks noGrp="1"/>
+          </p:cNvSpPr>
+          <p:nvPr>
+            <p:ph type="ftr" sz="quarter" idx="4"/>
+          </p:nvPr>
+        </p:nvSpPr>
+        <p:spPr>
+          <a:xfrm>
+            <a:off x="0" y="6502400"/>
+            <a:ext cx="3962400" cy="341313"/>
+          </a:xfrm>
+          <a:prstGeom prst="rect">
+            <a:avLst/>
+          </a:prstGeom>
+        </p:spPr>
+        <p:txBody>
+          <a:bodyPr vert="horz" lIns="91440" tIns="45720" rIns="91440" bIns="45720" rtlCol="0" anchor="b"/>
+          <a:lstStyle>
+            <a:lvl1pPr algn="l">
+              <a:defRPr sz="1200"/>
+            </a:lvl1pPr>
+          </a:lstStyle>
+          <a:p/>
+        </p:txBody>
+      </p:sp>
+      <p:sp>
+        <p:nvSpPr>
+          <p:cNvPr id="7" name="Slide Number Placeholder 6"/>
+          <p:cNvSpPr>
+            <a:spLocks noGrp="1"/>
+          </p:cNvSpPr>
+          <p:nvPr>
+            <p:ph type="sldNum" sz="quarter" idx="5"/>
+          </p:nvPr>
+        </p:nvSpPr>
+        <p:spPr>
+          <a:xfrm>
+            <a:off x="5180013" y="6502400"/>
+            <a:ext cx="3962400" cy="341313"/>
+          </a:xfrm>
+          <a:prstGeom prst="rect">
+            <a:avLst/>
+          </a:prstGeom>
+        </p:spPr>
+        <p:txBody>
+          <a:bodyPr vert="horz" lIns="91440" tIns="45720" rIns="91440" bIns="45720" rtlCol="0" anchor="b"/>
+          <a:lstStyle>
+            <a:lvl1pPr algn="r">
+              <a:defRPr sz="1200"/>
+            </a:lvl1pPr>
+          </a:lstStyle>
+          <a:p>
+            <a:r id="{871B2431-D351-4C6E-A3CF-9DFAC0E3E050}" type="slidenum">
+              <a:rPr lang="cs-CZ" smtClean="0"/>
+              <a:t>‹#›</a:t>
+            </a:r>
+          </a:p>
+        </p:txBody>
+      </p:sp>
+    </p:spTree>
+  </p:cSld>
+  <p:clrMapOvr>
+    <a:masterClrMapping/>
+  </p:clrMapOvr>
+</p:notes>
+</file>
+
+<file path=ppt/notesSlides/notesSlide23.xml><?xml version="1.0" encoding="utf-8"?>
 <p:notes xmlns:p="http://schemas.openxmlformats.org/presentationml/2006/main" xmlns:a="http://schemas.openxmlformats.org/drawingml/2006/main">
   <p:cSld>
     <p:spTree xmlns:r="http://schemas.openxmlformats.org/officeDocument/2006/relationships">
@@ -23782,7 +24053,7 @@
                 <a:cs typeface="Noto Sans SC"/>
                 <a:sym typeface="Noto Sans SC"/>
               </a:rPr>
-              <a:t>不是套壳：全栈开源，架构也较真</a:t>
+              <a:t>谁在你电脑上动手：三层分工</a:t>
             </a:r>
             <a:endParaRPr lang="en-US" sz="1100"/>
           </a:p>
@@ -23829,7 +24100,7 @@
                 <a:cs typeface="Noto Sans SC"/>
                 <a:sym typeface="Noto Sans SC"/>
               </a:rPr>
-              <a:t>开源范围是真实产品代码</a:t>
+              <a:t>服务端 + 多端壳：大脑与界面</a:t>
             </a:r>
             <a:endParaRPr lang="en-US" sz="1100"/>
           </a:p>
@@ -23844,7 +24115,7 @@
         <p:spPr>
           <a:xfrm rot="0" flipH="false" flipV="false">
             <a:off x="1016000" y="2476500"/>
-            <a:ext cx="4826000" cy="2032000"/>
+            <a:ext cx="4826000" cy="2286000"/>
           </a:xfrm>
           <a:prstGeom prst="rect">
             <a:avLst/>
@@ -23862,30 +24133,22 @@
           <a:p>
             <a:pPr algn="l" marL="0" indent="0">
               <a:lnSpc>
-                <a:spcPct val="166666"/>
-              </a:lnSpc>
-              <a:defRPr/>
-            </a:pPr>
-            <a:r>
-              <a:rPr lang="en-US" b="false" i="false" strike="noStrike" u="none" sz="1300">
-                <a:solidFill>
-                  <a:srgbClr val="475569"/>
+                <a:spcPct val="158333"/>
+              </a:lnSpc>
+              <a:defRPr/>
+            </a:pPr>
+            <a:r>
+              <a:rPr lang="en-US" b="true" i="false" strike="noStrike" u="none" sz="1300">
+                <a:solidFill>
+                  <a:srgbClr val="0D1326"/>
                 </a:solidFill>
                 <a:latin typeface="Noto Sans SC"/>
                 <a:ea typeface="Noto Sans SC"/>
                 <a:cs typeface="Noto Sans SC"/>
                 <a:sym typeface="Noto Sans SC"/>
               </a:rPr>
-              <a:t>· 桌面端（Electron）与移动端</a:t>
-            </a:r>
-            <a:endParaRPr lang="en-US" sz="1100"/>
-          </a:p>
-          <a:p>
-            <a:pPr algn="l" marL="0" indent="0">
-              <a:lnSpc>
-                <a:spcPct val="166666"/>
-              </a:lnSpc>
-            </a:pPr>
+              <a:t>服务端 tabtin_django</a:t>
+            </a:r>
             <a:r>
               <a:rPr lang="en-US" b="false" i="false" strike="noStrike" u="none" sz="1300">
                 <a:solidFill>
@@ -23896,13 +24159,14 @@
                 <a:cs typeface="Noto Sans SC"/>
                 <a:sym typeface="Noto Sans SC"/>
               </a:rPr>
-              <a:t>· 服务端 + Agent Runtime（569 文件）</a:t>
-            </a:r>
+              <a:t/>
+            </a:r>
+            <a:endParaRPr lang="en-US" sz="1100"/>
           </a:p>
           <a:p>
             <a:pPr algn="l" marL="0" indent="0">
               <a:lnSpc>
-                <a:spcPct val="166666"/>
+                <a:spcPct val="158333"/>
               </a:lnSpc>
             </a:pPr>
             <a:r>
@@ -23915,34 +24179,27 @@
                 <a:cs typeface="Noto Sans SC"/>
                 <a:sym typeface="Noto Sans SC"/>
               </a:rPr>
-              <a:t>· 实时协作（CRDT 消息 / 文档 / 表格 / PPT）</a:t>
+              <a:t>身份 · 任务 · 资产 · RAG · 记忆 · 权限——所有真源在这</a:t>
             </a:r>
           </a:p>
           <a:p>
             <a:pPr algn="l" marL="0" indent="0">
               <a:lnSpc>
-                <a:spcPct val="166666"/>
-              </a:lnSpc>
-            </a:pPr>
-            <a:r>
-              <a:rPr lang="en-US" b="false" i="false" strike="noStrike" u="none" sz="1300">
-                <a:solidFill>
-                  <a:srgbClr val="475569"/>
+                <a:spcPct val="158333"/>
+              </a:lnSpc>
+            </a:pPr>
+            <a:r>
+              <a:rPr lang="en-US" b="true" i="false" strike="noStrike" u="none" sz="1300">
+                <a:solidFill>
+                  <a:srgbClr val="0D1326"/>
                 </a:solidFill>
                 <a:latin typeface="Noto Sans SC"/>
                 <a:ea typeface="Noto Sans SC"/>
                 <a:cs typeface="Noto Sans SC"/>
                 <a:sym typeface="Noto Sans SC"/>
               </a:rPr>
-              <a:t>· 模型管理与管理后台</a:t>
-            </a:r>
-          </a:p>
-          <a:p>
-            <a:pPr algn="l" marL="0" indent="0">
-              <a:lnSpc>
-                <a:spcPct val="166666"/>
-              </a:lnSpc>
-            </a:pPr>
+              <a:t>多端壳</a:t>
+            </a:r>
             <a:r>
               <a:rPr lang="en-US" b="false" i="false" strike="noStrike" u="none" sz="1300">
                 <a:solidFill>
@@ -23953,7 +24210,26 @@
                 <a:cs typeface="Noto Sans SC"/>
                 <a:sym typeface="Noto Sans SC"/>
               </a:rPr>
-              <a:t>· 许可证 AGPL-3.0，可自部署</a:t>
+              <a:t/>
+            </a:r>
+          </a:p>
+          <a:p>
+            <a:pPr algn="l" marL="0" indent="0">
+              <a:lnSpc>
+                <a:spcPct val="158333"/>
+              </a:lnSpc>
+            </a:pPr>
+            <a:r>
+              <a:rPr lang="en-US" b="false" i="false" strike="noStrike" u="none" sz="1300">
+                <a:solidFill>
+                  <a:srgbClr val="475569"/>
+                </a:solidFill>
+                <a:latin typeface="Noto Sans SC"/>
+                <a:ea typeface="Noto Sans SC"/>
+                <a:cs typeface="Noto Sans SC"/>
+                <a:sym typeface="Noto Sans SC"/>
+              </a:rPr>
+              <a:t>Electron / Web / 安卓 / iOS——你操作的界面</a:t>
             </a:r>
           </a:p>
         </p:txBody>
@@ -23966,8 +24242,8 @@
         </p:nvCxnSpPr>
         <p:spPr>
           <a:xfrm rot="5385053" flipH="false" flipV="false">
-            <a:off x="4635486" y="3613178"/>
-            <a:ext cx="2921028" cy="12700"/>
+            <a:off x="4635500" y="3613164"/>
+            <a:ext cx="2921000" cy="12700"/>
           </a:xfrm>
           <a:prstGeom prst="straightConnector1">
             <a:avLst/>
@@ -24031,7 +24307,7 @@
                 <a:cs typeface="Noto Sans SC"/>
                 <a:sym typeface="Noto Sans SC"/>
               </a:rPr>
-              <a:t>三个架构决策，能看出它想做什么</a:t>
+              <a:t>本地 daemon：在真实机器上执行</a:t>
             </a:r>
             <a:endParaRPr lang="en-US" sz="1100"/>
           </a:p>
@@ -24046,7 +24322,7 @@
         <p:spPr>
           <a:xfrm rot="0" flipH="false" flipV="false">
             <a:off x="6477000" y="2476500"/>
-            <a:ext cx="4826000" cy="762000"/>
+            <a:ext cx="4826000" cy="698500"/>
           </a:xfrm>
           <a:prstGeom prst="rect">
             <a:avLst/>
@@ -24064,7 +24340,7 @@
           <a:p>
             <a:pPr algn="l" marL="0" indent="0">
               <a:lnSpc>
-                <a:spcPct val="133333"/>
+                <a:spcPct val="125000"/>
               </a:lnSpc>
               <a:defRPr/>
             </a:pPr>
@@ -24078,7 +24354,7 @@
                 <a:cs typeface="Noto Sans SC"/>
                 <a:sym typeface="Noto Sans SC"/>
               </a:rPr>
-              <a:t>Agent ≠ Device</a:t>
+              <a:t>terminal · browser · safe-fs</a:t>
             </a:r>
             <a:r>
               <a:rPr lang="en-US" b="false" i="false" strike="noStrike" u="none" sz="1200">
@@ -24090,7 +24366,7 @@
                 <a:cs typeface="Noto Sans SC"/>
                 <a:sym typeface="Noto Sans SC"/>
               </a:rPr>
-              <a:t>　身份和执行环境解耦——同一个 Agent 可以在不同电脑上跑，手机发起、桌面执行</a:t>
+              <a:t>　开终端、开浏览器、在授权目录读写</a:t>
             </a:r>
             <a:endParaRPr lang="en-US" sz="1100"/>
           </a:p>
@@ -24105,7 +24381,7 @@
         <p:spPr>
           <a:xfrm rot="0" flipH="false" flipV="false">
             <a:off x="6477000" y="3302000"/>
-            <a:ext cx="4826000" cy="762000"/>
+            <a:ext cx="4826000" cy="698500"/>
           </a:xfrm>
           <a:prstGeom prst="rect">
             <a:avLst/>
@@ -24123,7 +24399,7 @@
           <a:p>
             <a:pPr algn="l" marL="0" indent="0">
               <a:lnSpc>
-                <a:spcPct val="133333"/>
+                <a:spcPct val="125000"/>
               </a:lnSpc>
               <a:defRPr/>
             </a:pPr>
@@ -24137,7 +24413,7 @@
                 <a:cs typeface="Noto Sans SC"/>
                 <a:sym typeface="Noto Sans SC"/>
               </a:rPr>
-              <a:t>交接 ≠ 共享目录</a:t>
+              <a:t>python · mcp · skills</a:t>
             </a:r>
             <a:r>
               <a:rPr lang="en-US" b="false" i="false" strike="noStrike" u="none" sz="1200">
@@ -24149,7 +24425,7 @@
                 <a:cs typeface="Noto Sans SC"/>
                 <a:sym typeface="Noto Sans SC"/>
               </a:rPr>
-              <a:t>　Workspace 是私有的，交接只带引用材料和上下文，不把你的整个目录甩给同事</a:t>
+              <a:t>　跑脚本、连外部 MCP、加载技能</a:t>
             </a:r>
             <a:endParaRPr lang="en-US" sz="1100"/>
           </a:p>
@@ -24164,7 +24440,7 @@
         <p:spPr>
           <a:xfrm rot="0" flipH="false" flipV="false">
             <a:off x="6477000" y="4127500"/>
-            <a:ext cx="4826000" cy="762000"/>
+            <a:ext cx="4826000" cy="698500"/>
           </a:xfrm>
           <a:prstGeom prst="rect">
             <a:avLst/>
@@ -24182,21 +24458,21 @@
           <a:p>
             <a:pPr algn="l" marL="0" indent="0">
               <a:lnSpc>
-                <a:spcPct val="133333"/>
+                <a:spcPct val="125000"/>
               </a:lnSpc>
               <a:defRPr/>
             </a:pPr>
             <a:r>
               <a:rPr lang="en-US" b="true" i="false" strike="noStrike" u="none" sz="1200">
                 <a:solidFill>
-                  <a:srgbClr val="0D1326"/>
+                  <a:srgbClr val="C9302C"/>
                 </a:solidFill>
                 <a:latin typeface="Noto Sans SC"/>
                 <a:ea typeface="Noto Sans SC"/>
                 <a:cs typeface="Noto Sans SC"/>
                 <a:sym typeface="Noto Sans SC"/>
               </a:rPr>
-              <a:t>Shadow Git</a:t>
+              <a:t>security + gateway</a:t>
             </a:r>
             <a:r>
               <a:rPr lang="en-US" b="false" i="false" strike="noStrike" u="none" sz="1200">
@@ -24208,7 +24484,7 @@
                 <a:cs typeface="Noto Sans SC"/>
                 <a:sym typeface="Noto Sans SC"/>
               </a:rPr>
-              <a:t>　检查点挂在用户项目外的影子仓库，用 core.worktree 指向项目——不污染你自己的 .git</a:t>
+              <a:t>　审批三档 · 每 run 预算 · 长连收任务回传</a:t>
             </a:r>
             <a:endParaRPr lang="en-US" sz="1100"/>
           </a:p>
@@ -24223,7 +24499,7 @@
         <p:spPr>
           <a:xfrm rot="-4297" flipH="false" flipV="false">
             <a:off x="1016004" y="5454650"/>
-            <a:ext cx="10160008" cy="12700"/>
+            <a:ext cx="10160000" cy="12700"/>
           </a:xfrm>
           <a:prstGeom prst="straightConnector1">
             <a:avLst/>
@@ -24287,7 +24563,7 @@
                 <a:cs typeface="Noto Sans SC"/>
                 <a:sym typeface="Noto Sans SC"/>
               </a:rPr>
-              <a:t>当前 Public Preview（公开预览）阶段 · github.com/tabtin-ai/TabTin · 官网 tabtin.com</a:t>
+              <a:t>Agent 在服务端、界面在多端，真正动手的是这台机器上的 daemon——这就是「Agent≠Device」。</a:t>
             </a:r>
             <a:endParaRPr lang="en-US" sz="1100"/>
           </a:p>
@@ -24302,6 +24578,1017 @@
 </file>
 
 <file path=ppt/slides/slide19.xml><?xml version="1.0" encoding="utf-8"?>
+<p:sld xmlns:p="http://schemas.openxmlformats.org/presentationml/2006/main" xmlns:a="http://schemas.openxmlformats.org/drawingml/2006/main">
+  <p:cSld>
+    <p:bg>
+      <p:bgPr>
+        <a:solidFill>
+          <a:srgbClr val="FFFFFF">
+            <a:alpha val="100000"/>
+          </a:srgbClr>
+        </a:solidFill>
+      </p:bgPr>
+    </p:bg>
+    <p:spTree>
+      <p:nvGrpSpPr>
+        <p:cNvPr id="1" name=""/>
+        <p:cNvGrpSpPr/>
+        <p:nvPr/>
+      </p:nvGrpSpPr>
+      <p:grpSpPr>
+        <a:xfrm>
+          <a:off x="0" y="0"/>
+          <a:ext cx="0" cy="0"/>
+          <a:chOff x="0" y="0"/>
+          <a:chExt cx="0" cy="0"/>
+        </a:xfrm>
+      </p:grpSpPr>
+      <p:sp>
+        <p:nvSpPr>
+          <p:cNvPr name="AutoShape 2" id="2"/>
+          <p:cNvSpPr/>
+          <p:nvPr/>
+        </p:nvSpPr>
+        <p:spPr>
+          <a:xfrm rot="0" flipH="false" flipV="false">
+            <a:off x="1016000" y="762000"/>
+            <a:ext cx="5080000" cy="254000"/>
+          </a:xfrm>
+          <a:prstGeom prst="rect">
+            <a:avLst/>
+          </a:prstGeom>
+          <a:noFill/>
+          <a:ln w="12700" cmpd="sng" cap="flat">
+            <a:noFill/>
+            <a:prstDash val="solid"/>
+            <a:round/>
+          </a:ln>
+        </p:spPr>
+        <p:txBody>
+          <a:bodyPr anchor="ctr" rtlCol="false" anchorCtr="false" vert="horz" wrap="square" lIns="0" rIns="0" tIns="0" bIns="0"/>
+          <a:lstStyle/>
+          <a:p>
+            <a:pPr algn="l" marL="0" indent="0">
+              <a:lnSpc>
+                <a:spcPct val="125000"/>
+              </a:lnSpc>
+              <a:defRPr/>
+            </a:pPr>
+            <a:r>
+              <a:rPr lang="en-US" b="false" i="false" strike="noStrike" u="none" sz="1100">
+                <a:solidFill>
+                  <a:srgbClr val="94A3B8"/>
+                </a:solidFill>
+                <a:latin typeface="Noto Sans SC"/>
+                <a:ea typeface="Noto Sans SC"/>
+                <a:cs typeface="Noto Sans SC"/>
+                <a:sym typeface="Noto Sans SC"/>
+              </a:rPr>
+              <a:t>04 · 一个开源项目的观察</a:t>
+            </a:r>
+            <a:endParaRPr lang="en-US" sz="1100"/>
+          </a:p>
+        </p:txBody>
+      </p:sp>
+      <p:sp>
+        <p:nvSpPr>
+          <p:cNvPr name="AutoShape 3" id="3"/>
+          <p:cNvSpPr/>
+          <p:nvPr/>
+        </p:nvSpPr>
+        <p:spPr>
+          <a:xfrm rot="0" flipH="false" flipV="false">
+            <a:off x="1016000" y="1206500"/>
+            <a:ext cx="10160000" cy="508000"/>
+          </a:xfrm>
+          <a:prstGeom prst="rect">
+            <a:avLst/>
+          </a:prstGeom>
+          <a:noFill/>
+          <a:ln w="12700" cmpd="sng" cap="flat">
+            <a:noFill/>
+            <a:prstDash val="solid"/>
+            <a:round/>
+          </a:ln>
+        </p:spPr>
+        <p:txBody>
+          <a:bodyPr anchor="ctr" rtlCol="false" anchorCtr="false" vert="horz" wrap="square" lIns="0" rIns="0" tIns="0" bIns="0"/>
+          <a:lstStyle/>
+          <a:p>
+            <a:pPr algn="l" marL="0" indent="0">
+              <a:lnSpc>
+                <a:spcPct val="125000"/>
+              </a:lnSpc>
+              <a:defRPr/>
+            </a:pPr>
+            <a:r>
+              <a:rPr lang="en-US" b="true" i="false" strike="noStrike" u="none" sz="2800">
+                <a:solidFill>
+                  <a:srgbClr val="0D1326"/>
+                </a:solidFill>
+                <a:latin typeface="Noto Sans SC"/>
+                <a:ea typeface="Noto Sans SC"/>
+                <a:cs typeface="Noto Sans SC"/>
+                <a:sym typeface="Noto Sans SC"/>
+              </a:rPr>
+              <a:t>不是套壳：全栈开源，架构也较真</a:t>
+            </a:r>
+            <a:endParaRPr lang="en-US" sz="1100"/>
+          </a:p>
+        </p:txBody>
+      </p:sp>
+      <p:sp>
+        <p:nvSpPr>
+          <p:cNvPr name="AutoShape 4" id="4"/>
+          <p:cNvSpPr/>
+          <p:nvPr/>
+        </p:nvSpPr>
+        <p:spPr>
+          <a:xfrm rot="0" flipH="false" flipV="false">
+            <a:off x="1016000" y="2095500"/>
+            <a:ext cx="4826000" cy="304800"/>
+          </a:xfrm>
+          <a:prstGeom prst="rect">
+            <a:avLst/>
+          </a:prstGeom>
+          <a:noFill/>
+          <a:ln w="12700" cmpd="sng" cap="flat">
+            <a:noFill/>
+            <a:prstDash val="solid"/>
+            <a:round/>
+          </a:ln>
+        </p:spPr>
+        <p:txBody>
+          <a:bodyPr anchor="ctr" rtlCol="false" anchorCtr="false" vert="horz" wrap="square" lIns="0" rIns="0" tIns="0" bIns="0"/>
+          <a:lstStyle/>
+          <a:p>
+            <a:pPr algn="l" marL="0" indent="0">
+              <a:lnSpc>
+                <a:spcPct val="125000"/>
+              </a:lnSpc>
+              <a:defRPr/>
+            </a:pPr>
+            <a:r>
+              <a:rPr lang="en-US" b="true" i="false" strike="noStrike" u="none" sz="1400">
+                <a:solidFill>
+                  <a:srgbClr val="0D1326"/>
+                </a:solidFill>
+                <a:latin typeface="Noto Sans SC"/>
+                <a:ea typeface="Noto Sans SC"/>
+                <a:cs typeface="Noto Sans SC"/>
+                <a:sym typeface="Noto Sans SC"/>
+              </a:rPr>
+              <a:t>开源范围是真实产品代码</a:t>
+            </a:r>
+            <a:endParaRPr lang="en-US" sz="1100"/>
+          </a:p>
+        </p:txBody>
+      </p:sp>
+      <p:sp>
+        <p:nvSpPr>
+          <p:cNvPr name="AutoShape 5" id="5"/>
+          <p:cNvSpPr/>
+          <p:nvPr/>
+        </p:nvSpPr>
+        <p:spPr>
+          <a:xfrm rot="0" flipH="false" flipV="false">
+            <a:off x="1016000" y="2476500"/>
+            <a:ext cx="4826000" cy="2032000"/>
+          </a:xfrm>
+          <a:prstGeom prst="rect">
+            <a:avLst/>
+          </a:prstGeom>
+          <a:noFill/>
+          <a:ln w="12700" cmpd="sng" cap="flat">
+            <a:noFill/>
+            <a:prstDash val="solid"/>
+            <a:round/>
+          </a:ln>
+        </p:spPr>
+        <p:txBody>
+          <a:bodyPr anchor="ctr" rtlCol="false" anchorCtr="false" vert="horz" wrap="square" lIns="0" rIns="0" tIns="0" bIns="0"/>
+          <a:lstStyle/>
+          <a:p>
+            <a:pPr algn="l" marL="0" indent="0">
+              <a:lnSpc>
+                <a:spcPct val="166666"/>
+              </a:lnSpc>
+              <a:defRPr/>
+            </a:pPr>
+            <a:r>
+              <a:rPr lang="en-US" b="false" i="false" strike="noStrike" u="none" sz="1300">
+                <a:solidFill>
+                  <a:srgbClr val="475569"/>
+                </a:solidFill>
+                <a:latin typeface="Noto Sans SC"/>
+                <a:ea typeface="Noto Sans SC"/>
+                <a:cs typeface="Noto Sans SC"/>
+                <a:sym typeface="Noto Sans SC"/>
+              </a:rPr>
+              <a:t>· 桌面端（Electron）与移动端</a:t>
+            </a:r>
+            <a:endParaRPr lang="en-US" sz="1100"/>
+          </a:p>
+          <a:p>
+            <a:pPr algn="l" marL="0" indent="0">
+              <a:lnSpc>
+                <a:spcPct val="166666"/>
+              </a:lnSpc>
+            </a:pPr>
+            <a:r>
+              <a:rPr lang="en-US" b="false" i="false" strike="noStrike" u="none" sz="1300">
+                <a:solidFill>
+                  <a:srgbClr val="475569"/>
+                </a:solidFill>
+                <a:latin typeface="Noto Sans SC"/>
+                <a:ea typeface="Noto Sans SC"/>
+                <a:cs typeface="Noto Sans SC"/>
+                <a:sym typeface="Noto Sans SC"/>
+              </a:rPr>
+              <a:t>· 服务端 + Agent Runtime（569 文件）</a:t>
+            </a:r>
+          </a:p>
+          <a:p>
+            <a:pPr algn="l" marL="0" indent="0">
+              <a:lnSpc>
+                <a:spcPct val="166666"/>
+              </a:lnSpc>
+            </a:pPr>
+            <a:r>
+              <a:rPr lang="en-US" b="false" i="false" strike="noStrike" u="none" sz="1300">
+                <a:solidFill>
+                  <a:srgbClr val="475569"/>
+                </a:solidFill>
+                <a:latin typeface="Noto Sans SC"/>
+                <a:ea typeface="Noto Sans SC"/>
+                <a:cs typeface="Noto Sans SC"/>
+                <a:sym typeface="Noto Sans SC"/>
+              </a:rPr>
+              <a:t>· 实时协作（CRDT 消息 / 文档 / 表格 / PPT）</a:t>
+            </a:r>
+          </a:p>
+          <a:p>
+            <a:pPr algn="l" marL="0" indent="0">
+              <a:lnSpc>
+                <a:spcPct val="166666"/>
+              </a:lnSpc>
+            </a:pPr>
+            <a:r>
+              <a:rPr lang="en-US" b="false" i="false" strike="noStrike" u="none" sz="1300">
+                <a:solidFill>
+                  <a:srgbClr val="475569"/>
+                </a:solidFill>
+                <a:latin typeface="Noto Sans SC"/>
+                <a:ea typeface="Noto Sans SC"/>
+                <a:cs typeface="Noto Sans SC"/>
+                <a:sym typeface="Noto Sans SC"/>
+              </a:rPr>
+              <a:t>· 模型管理与管理后台</a:t>
+            </a:r>
+          </a:p>
+          <a:p>
+            <a:pPr algn="l" marL="0" indent="0">
+              <a:lnSpc>
+                <a:spcPct val="166666"/>
+              </a:lnSpc>
+            </a:pPr>
+            <a:r>
+              <a:rPr lang="en-US" b="false" i="false" strike="noStrike" u="none" sz="1300">
+                <a:solidFill>
+                  <a:srgbClr val="475569"/>
+                </a:solidFill>
+                <a:latin typeface="Noto Sans SC"/>
+                <a:ea typeface="Noto Sans SC"/>
+                <a:cs typeface="Noto Sans SC"/>
+                <a:sym typeface="Noto Sans SC"/>
+              </a:rPr>
+              <a:t>· 许可证 AGPL-3.0，可自部署</a:t>
+            </a:r>
+          </a:p>
+        </p:txBody>
+      </p:sp>
+      <p:cxnSp>
+        <p:nvCxnSpPr>
+          <p:cNvPr name="Connector 6" id="6"/>
+          <p:cNvCxnSpPr/>
+          <p:nvPr/>
+        </p:nvCxnSpPr>
+        <p:spPr>
+          <a:xfrm rot="5385053" flipH="false" flipV="false">
+            <a:off x="4635486" y="3613178"/>
+            <a:ext cx="2921028" cy="12700"/>
+          </a:xfrm>
+          <a:prstGeom prst="straightConnector1">
+            <a:avLst/>
+          </a:prstGeom>
+          <a:solidFill>
+            <a:srgbClr val="DEE0E3">
+              <a:alpha val="100000"/>
+            </a:srgbClr>
+          </a:solidFill>
+          <a:ln w="12700" cmpd="sng" cap="flat">
+            <a:solidFill>
+              <a:srgbClr val="E5E7EB">
+                <a:alpha val="100000"/>
+              </a:srgbClr>
+            </a:solidFill>
+            <a:prstDash val="solid"/>
+            <a:round/>
+            <a:headEnd type="none" w="med" len="med"/>
+            <a:tailEnd type="none" w="med" len="med"/>
+          </a:ln>
+        </p:spPr>
+      </p:cxnSp>
+      <p:sp>
+        <p:nvSpPr>
+          <p:cNvPr name="AutoShape 7" id="7"/>
+          <p:cNvSpPr/>
+          <p:nvPr/>
+        </p:nvSpPr>
+        <p:spPr>
+          <a:xfrm rot="0" flipH="false" flipV="false">
+            <a:off x="6477000" y="2095500"/>
+            <a:ext cx="4826000" cy="304800"/>
+          </a:xfrm>
+          <a:prstGeom prst="rect">
+            <a:avLst/>
+          </a:prstGeom>
+          <a:noFill/>
+          <a:ln w="12700" cmpd="sng" cap="flat">
+            <a:noFill/>
+            <a:prstDash val="solid"/>
+            <a:round/>
+          </a:ln>
+        </p:spPr>
+        <p:txBody>
+          <a:bodyPr anchor="ctr" rtlCol="false" anchorCtr="false" vert="horz" wrap="square" lIns="0" rIns="0" tIns="0" bIns="0"/>
+          <a:lstStyle/>
+          <a:p>
+            <a:pPr algn="l" marL="0" indent="0">
+              <a:lnSpc>
+                <a:spcPct val="125000"/>
+              </a:lnSpc>
+              <a:defRPr/>
+            </a:pPr>
+            <a:r>
+              <a:rPr lang="en-US" b="true" i="false" strike="noStrike" u="none" sz="1400">
+                <a:solidFill>
+                  <a:srgbClr val="0D1326"/>
+                </a:solidFill>
+                <a:latin typeface="Noto Sans SC"/>
+                <a:ea typeface="Noto Sans SC"/>
+                <a:cs typeface="Noto Sans SC"/>
+                <a:sym typeface="Noto Sans SC"/>
+              </a:rPr>
+              <a:t>三个架构决策，能看出它想做什么</a:t>
+            </a:r>
+            <a:endParaRPr lang="en-US" sz="1100"/>
+          </a:p>
+        </p:txBody>
+      </p:sp>
+      <p:sp>
+        <p:nvSpPr>
+          <p:cNvPr name="AutoShape 8" id="8"/>
+          <p:cNvSpPr/>
+          <p:nvPr/>
+        </p:nvSpPr>
+        <p:spPr>
+          <a:xfrm rot="0" flipH="false" flipV="false">
+            <a:off x="6477000" y="2476500"/>
+            <a:ext cx="4826000" cy="762000"/>
+          </a:xfrm>
+          <a:prstGeom prst="rect">
+            <a:avLst/>
+          </a:prstGeom>
+          <a:noFill/>
+          <a:ln w="12700" cmpd="sng" cap="flat">
+            <a:noFill/>
+            <a:prstDash val="solid"/>
+            <a:round/>
+          </a:ln>
+        </p:spPr>
+        <p:txBody>
+          <a:bodyPr anchor="ctr" rtlCol="false" anchorCtr="false" vert="horz" wrap="square" lIns="0" rIns="0" tIns="0" bIns="0"/>
+          <a:lstStyle/>
+          <a:p>
+            <a:pPr algn="l" marL="0" indent="0">
+              <a:lnSpc>
+                <a:spcPct val="133333"/>
+              </a:lnSpc>
+              <a:defRPr/>
+            </a:pPr>
+            <a:r>
+              <a:rPr lang="en-US" b="true" i="false" strike="noStrike" u="none" sz="1200">
+                <a:solidFill>
+                  <a:srgbClr val="0D1326"/>
+                </a:solidFill>
+                <a:latin typeface="Noto Sans SC"/>
+                <a:ea typeface="Noto Sans SC"/>
+                <a:cs typeface="Noto Sans SC"/>
+                <a:sym typeface="Noto Sans SC"/>
+              </a:rPr>
+              <a:t>Agent ≠ Device</a:t>
+            </a:r>
+            <a:r>
+              <a:rPr lang="en-US" b="false" i="false" strike="noStrike" u="none" sz="1200">
+                <a:solidFill>
+                  <a:srgbClr val="475569"/>
+                </a:solidFill>
+                <a:latin typeface="Noto Sans SC"/>
+                <a:ea typeface="Noto Sans SC"/>
+                <a:cs typeface="Noto Sans SC"/>
+                <a:sym typeface="Noto Sans SC"/>
+              </a:rPr>
+              <a:t>　身份和执行环境解耦——同一个 Agent 可以在不同电脑上跑，手机发起、桌面执行</a:t>
+            </a:r>
+            <a:endParaRPr lang="en-US" sz="1100"/>
+          </a:p>
+        </p:txBody>
+      </p:sp>
+      <p:sp>
+        <p:nvSpPr>
+          <p:cNvPr name="AutoShape 9" id="9"/>
+          <p:cNvSpPr/>
+          <p:nvPr/>
+        </p:nvSpPr>
+        <p:spPr>
+          <a:xfrm rot="0" flipH="false" flipV="false">
+            <a:off x="6477000" y="3302000"/>
+            <a:ext cx="4826000" cy="762000"/>
+          </a:xfrm>
+          <a:prstGeom prst="rect">
+            <a:avLst/>
+          </a:prstGeom>
+          <a:noFill/>
+          <a:ln w="12700" cmpd="sng" cap="flat">
+            <a:noFill/>
+            <a:prstDash val="solid"/>
+            <a:round/>
+          </a:ln>
+        </p:spPr>
+        <p:txBody>
+          <a:bodyPr anchor="ctr" rtlCol="false" anchorCtr="false" vert="horz" wrap="square" lIns="0" rIns="0" tIns="0" bIns="0"/>
+          <a:lstStyle/>
+          <a:p>
+            <a:pPr algn="l" marL="0" indent="0">
+              <a:lnSpc>
+                <a:spcPct val="133333"/>
+              </a:lnSpc>
+              <a:defRPr/>
+            </a:pPr>
+            <a:r>
+              <a:rPr lang="en-US" b="true" i="false" strike="noStrike" u="none" sz="1200">
+                <a:solidFill>
+                  <a:srgbClr val="0D1326"/>
+                </a:solidFill>
+                <a:latin typeface="Noto Sans SC"/>
+                <a:ea typeface="Noto Sans SC"/>
+                <a:cs typeface="Noto Sans SC"/>
+                <a:sym typeface="Noto Sans SC"/>
+              </a:rPr>
+              <a:t>交接 ≠ 共享目录</a:t>
+            </a:r>
+            <a:r>
+              <a:rPr lang="en-US" b="false" i="false" strike="noStrike" u="none" sz="1200">
+                <a:solidFill>
+                  <a:srgbClr val="475569"/>
+                </a:solidFill>
+                <a:latin typeface="Noto Sans SC"/>
+                <a:ea typeface="Noto Sans SC"/>
+                <a:cs typeface="Noto Sans SC"/>
+                <a:sym typeface="Noto Sans SC"/>
+              </a:rPr>
+              <a:t>　Workspace 是私有的，交接只带引用材料和上下文，不把你的整个目录甩给同事</a:t>
+            </a:r>
+            <a:endParaRPr lang="en-US" sz="1100"/>
+          </a:p>
+        </p:txBody>
+      </p:sp>
+      <p:sp>
+        <p:nvSpPr>
+          <p:cNvPr name="AutoShape 10" id="10"/>
+          <p:cNvSpPr/>
+          <p:nvPr/>
+        </p:nvSpPr>
+        <p:spPr>
+          <a:xfrm rot="0" flipH="false" flipV="false">
+            <a:off x="6477000" y="4127500"/>
+            <a:ext cx="4826000" cy="762000"/>
+          </a:xfrm>
+          <a:prstGeom prst="rect">
+            <a:avLst/>
+          </a:prstGeom>
+          <a:noFill/>
+          <a:ln w="12700" cmpd="sng" cap="flat">
+            <a:noFill/>
+            <a:prstDash val="solid"/>
+            <a:round/>
+          </a:ln>
+        </p:spPr>
+        <p:txBody>
+          <a:bodyPr anchor="ctr" rtlCol="false" anchorCtr="false" vert="horz" wrap="square" lIns="0" rIns="0" tIns="0" bIns="0"/>
+          <a:lstStyle/>
+          <a:p>
+            <a:pPr algn="l" marL="0" indent="0">
+              <a:lnSpc>
+                <a:spcPct val="133333"/>
+              </a:lnSpc>
+              <a:defRPr/>
+            </a:pPr>
+            <a:r>
+              <a:rPr lang="en-US" b="true" i="false" strike="noStrike" u="none" sz="1200">
+                <a:solidFill>
+                  <a:srgbClr val="0D1326"/>
+                </a:solidFill>
+                <a:latin typeface="Noto Sans SC"/>
+                <a:ea typeface="Noto Sans SC"/>
+                <a:cs typeface="Noto Sans SC"/>
+                <a:sym typeface="Noto Sans SC"/>
+              </a:rPr>
+              <a:t>Shadow Git</a:t>
+            </a:r>
+            <a:r>
+              <a:rPr lang="en-US" b="false" i="false" strike="noStrike" u="none" sz="1200">
+                <a:solidFill>
+                  <a:srgbClr val="475569"/>
+                </a:solidFill>
+                <a:latin typeface="Noto Sans SC"/>
+                <a:ea typeface="Noto Sans SC"/>
+                <a:cs typeface="Noto Sans SC"/>
+                <a:sym typeface="Noto Sans SC"/>
+              </a:rPr>
+              <a:t>　检查点挂在用户项目外的影子仓库，用 core.worktree 指向项目——不污染你自己的 .git</a:t>
+            </a:r>
+            <a:endParaRPr lang="en-US" sz="1100"/>
+          </a:p>
+        </p:txBody>
+      </p:sp>
+      <p:cxnSp>
+        <p:nvCxnSpPr>
+          <p:cNvPr name="Connector 11" id="11"/>
+          <p:cNvCxnSpPr/>
+          <p:nvPr/>
+        </p:nvCxnSpPr>
+        <p:spPr>
+          <a:xfrm rot="-4297" flipH="false" flipV="false">
+            <a:off x="1016004" y="5454650"/>
+            <a:ext cx="10160008" cy="12700"/>
+          </a:xfrm>
+          <a:prstGeom prst="straightConnector1">
+            <a:avLst/>
+          </a:prstGeom>
+          <a:solidFill>
+            <a:srgbClr val="DEE0E3">
+              <a:alpha val="100000"/>
+            </a:srgbClr>
+          </a:solidFill>
+          <a:ln w="12700" cmpd="sng" cap="flat">
+            <a:solidFill>
+              <a:srgbClr val="E5E7EB">
+                <a:alpha val="100000"/>
+              </a:srgbClr>
+            </a:solidFill>
+            <a:prstDash val="solid"/>
+            <a:round/>
+            <a:headEnd type="none" w="med" len="med"/>
+            <a:tailEnd type="none" w="med" len="med"/>
+          </a:ln>
+        </p:spPr>
+      </p:cxnSp>
+      <p:sp>
+        <p:nvSpPr>
+          <p:cNvPr name="AutoShape 12" id="12"/>
+          <p:cNvSpPr/>
+          <p:nvPr/>
+        </p:nvSpPr>
+        <p:spPr>
+          <a:xfrm rot="0" flipH="false" flipV="false">
+            <a:off x="1016000" y="5651500"/>
+            <a:ext cx="10160000" cy="381000"/>
+          </a:xfrm>
+          <a:prstGeom prst="rect">
+            <a:avLst/>
+          </a:prstGeom>
+          <a:noFill/>
+          <a:ln w="12700" cmpd="sng" cap="flat">
+            <a:noFill/>
+            <a:prstDash val="solid"/>
+            <a:round/>
+          </a:ln>
+        </p:spPr>
+        <p:txBody>
+          <a:bodyPr anchor="ctr" rtlCol="false" anchorCtr="false" vert="horz" wrap="square" lIns="0" rIns="0" tIns="0" bIns="0"/>
+          <a:lstStyle/>
+          <a:p>
+            <a:pPr algn="l" marL="0" indent="0">
+              <a:lnSpc>
+                <a:spcPct val="125000"/>
+              </a:lnSpc>
+              <a:defRPr/>
+            </a:pPr>
+            <a:r>
+              <a:rPr lang="en-US" b="false" i="false" strike="noStrike" u="none" sz="1200">
+                <a:solidFill>
+                  <a:srgbClr val="64748B"/>
+                </a:solidFill>
+                <a:latin typeface="Noto Sans SC"/>
+                <a:ea typeface="Noto Sans SC"/>
+                <a:cs typeface="Noto Sans SC"/>
+                <a:sym typeface="Noto Sans SC"/>
+              </a:rPr>
+              <a:t>当前 Public Preview（公开预览）阶段 · github.com/tabtin-ai/TabTin · 官网 tabtin.com</a:t>
+            </a:r>
+            <a:endParaRPr lang="en-US" sz="1100"/>
+          </a:p>
+        </p:txBody>
+      </p:sp>
+    </p:spTree>
+  </p:cSld>
+  <p:clrMapOvr>
+    <a:masterClrMapping/>
+  </p:clrMapOvr>
+</p:sld>
+</file>
+
+<file path=ppt/slides/slide2.xml><?xml version="1.0" encoding="utf-8"?>
+<p:sld xmlns:p="http://schemas.openxmlformats.org/presentationml/2006/main" xmlns:a="http://schemas.openxmlformats.org/drawingml/2006/main">
+  <p:cSld>
+    <p:bg>
+      <p:bgPr>
+        <a:solidFill>
+          <a:srgbClr val="FFFFFF">
+            <a:alpha val="100000"/>
+          </a:srgbClr>
+        </a:solidFill>
+      </p:bgPr>
+    </p:bg>
+    <p:spTree>
+      <p:nvGrpSpPr>
+        <p:cNvPr id="1" name=""/>
+        <p:cNvGrpSpPr/>
+        <p:nvPr/>
+      </p:nvGrpSpPr>
+      <p:grpSpPr>
+        <a:xfrm>
+          <a:off x="0" y="0"/>
+          <a:ext cx="0" cy="0"/>
+          <a:chOff x="0" y="0"/>
+          <a:chExt cx="0" cy="0"/>
+        </a:xfrm>
+      </p:grpSpPr>
+      <p:sp>
+        <p:nvSpPr>
+          <p:cNvPr name="AutoShape 2" id="2"/>
+          <p:cNvSpPr/>
+          <p:nvPr/>
+        </p:nvSpPr>
+        <p:spPr>
+          <a:xfrm rot="0" flipH="false" flipV="false">
+            <a:off x="1016000" y="762000"/>
+            <a:ext cx="5080000" cy="254000"/>
+          </a:xfrm>
+          <a:prstGeom prst="rect">
+            <a:avLst/>
+          </a:prstGeom>
+          <a:noFill/>
+          <a:ln w="12700" cmpd="sng" cap="flat">
+            <a:noFill/>
+            <a:prstDash val="solid"/>
+            <a:round/>
+          </a:ln>
+        </p:spPr>
+        <p:txBody>
+          <a:bodyPr anchor="ctr" rtlCol="false" anchorCtr="false" vert="horz" wrap="square" lIns="0" rIns="0" tIns="0" bIns="0"/>
+          <a:lstStyle/>
+          <a:p>
+            <a:pPr algn="l" marL="0" indent="0">
+              <a:lnSpc>
+                <a:spcPct val="125000"/>
+              </a:lnSpc>
+              <a:defRPr/>
+            </a:pPr>
+            <a:r>
+              <a:rPr lang="en-US" b="false" i="false" strike="noStrike" u="none" sz="1100">
+                <a:solidFill>
+                  <a:srgbClr val="94A3B8"/>
+                </a:solidFill>
+                <a:latin typeface="Noto Sans SC"/>
+                <a:ea typeface="Noto Sans SC"/>
+                <a:cs typeface="Noto Sans SC"/>
+                <a:sym typeface="Noto Sans SC"/>
+              </a:rPr>
+              <a:t>01 · 开场</a:t>
+            </a:r>
+            <a:endParaRPr lang="en-US" sz="1100"/>
+          </a:p>
+        </p:txBody>
+      </p:sp>
+      <p:sp>
+        <p:nvSpPr>
+          <p:cNvPr name="AutoShape 3" id="3"/>
+          <p:cNvSpPr/>
+          <p:nvPr/>
+        </p:nvSpPr>
+        <p:spPr>
+          <a:xfrm rot="0" flipH="false" flipV="false">
+            <a:off x="1016000" y="1206500"/>
+            <a:ext cx="10160000" cy="635000"/>
+          </a:xfrm>
+          <a:prstGeom prst="rect">
+            <a:avLst/>
+          </a:prstGeom>
+          <a:noFill/>
+          <a:ln w="12700" cmpd="sng" cap="flat">
+            <a:noFill/>
+            <a:prstDash val="solid"/>
+            <a:round/>
+          </a:ln>
+        </p:spPr>
+        <p:txBody>
+          <a:bodyPr anchor="ctr" rtlCol="false" anchorCtr="false" vert="horz" wrap="square" lIns="0" rIns="0" tIns="0" bIns="0"/>
+          <a:lstStyle/>
+          <a:p>
+            <a:pPr algn="l" marL="0" indent="0">
+              <a:lnSpc>
+                <a:spcPct val="125000"/>
+              </a:lnSpc>
+              <a:defRPr/>
+            </a:pPr>
+            <a:r>
+              <a:rPr lang="en-US" b="true" i="false" strike="noStrike" u="none" sz="3200">
+                <a:solidFill>
+                  <a:srgbClr val="0D1326"/>
+                </a:solidFill>
+                <a:latin typeface="Noto Sans SC"/>
+                <a:ea typeface="Noto Sans SC"/>
+                <a:cs typeface="Noto Sans SC"/>
+                <a:sym typeface="Noto Sans SC"/>
+              </a:rPr>
+              <a:t>你让 AI 做的东西，同事接得住吗？</a:t>
+            </a:r>
+            <a:endParaRPr lang="en-US" sz="1100"/>
+          </a:p>
+        </p:txBody>
+      </p:sp>
+      <p:cxnSp>
+        <p:nvCxnSpPr>
+          <p:cNvPr name="Connector 4" id="4"/>
+          <p:cNvCxnSpPr/>
+          <p:nvPr/>
+        </p:nvCxnSpPr>
+        <p:spPr>
+          <a:xfrm rot="-4297" flipH="false" flipV="false">
+            <a:off x="1016004" y="2152650"/>
+            <a:ext cx="10160008" cy="12700"/>
+          </a:xfrm>
+          <a:prstGeom prst="straightConnector1">
+            <a:avLst/>
+          </a:prstGeom>
+          <a:solidFill>
+            <a:srgbClr val="DEE0E3">
+              <a:alpha val="100000"/>
+            </a:srgbClr>
+          </a:solidFill>
+          <a:ln w="12700" cmpd="sng" cap="flat">
+            <a:solidFill>
+              <a:srgbClr val="E5E7EB">
+                <a:alpha val="100000"/>
+              </a:srgbClr>
+            </a:solidFill>
+            <a:prstDash val="solid"/>
+            <a:round/>
+            <a:headEnd type="none" w="med" len="med"/>
+            <a:tailEnd type="none" w="med" len="med"/>
+          </a:ln>
+        </p:spPr>
+      </p:cxnSp>
+      <p:sp>
+        <p:nvSpPr>
+          <p:cNvPr name="AutoShape 5" id="5"/>
+          <p:cNvSpPr/>
+          <p:nvPr/>
+        </p:nvSpPr>
+        <p:spPr>
+          <a:xfrm rot="0" flipH="false" flipV="false">
+            <a:off x="1016000" y="2540000"/>
+            <a:ext cx="10160000" cy="1524000"/>
+          </a:xfrm>
+          <a:prstGeom prst="rect">
+            <a:avLst/>
+          </a:prstGeom>
+          <a:noFill/>
+          <a:ln w="12700" cmpd="sng" cap="flat">
+            <a:noFill/>
+            <a:prstDash val="solid"/>
+            <a:round/>
+          </a:ln>
+        </p:spPr>
+        <p:txBody>
+          <a:bodyPr anchor="ctr" rtlCol="false" anchorCtr="false" vert="horz" wrap="square" lIns="0" rIns="0" tIns="0" bIns="0"/>
+          <a:lstStyle/>
+          <a:p>
+            <a:pPr algn="l" marL="0" indent="0">
+              <a:lnSpc>
+                <a:spcPct val="150000"/>
+              </a:lnSpc>
+              <a:defRPr/>
+            </a:pPr>
+            <a:r>
+              <a:rPr lang="en-US" b="false" i="false" strike="noStrike" u="none" sz="1800">
+                <a:solidFill>
+                  <a:srgbClr val="475569"/>
+                </a:solidFill>
+                <a:latin typeface="Noto Sans SC"/>
+                <a:ea typeface="Noto Sans SC"/>
+                <a:cs typeface="Noto Sans SC"/>
+                <a:sym typeface="Noto Sans SC"/>
+              </a:rPr>
+              <a:t>你昨天让 AI 帮你做了一下午竞品调研，今天同事接手，</a:t>
+            </a:r>
+            <a:endParaRPr lang="en-US" sz="1100"/>
+          </a:p>
+          <a:p>
+            <a:pPr algn="l" marL="0" indent="0">
+              <a:lnSpc>
+                <a:spcPct val="150000"/>
+              </a:lnSpc>
+            </a:pPr>
+            <a:r>
+              <a:rPr lang="en-US" b="false" i="false" strike="noStrike" u="none" sz="1800">
+                <a:solidFill>
+                  <a:srgbClr val="475569"/>
+                </a:solidFill>
+                <a:latin typeface="Noto Sans SC"/>
+                <a:ea typeface="Noto Sans SC"/>
+                <a:cs typeface="Noto Sans SC"/>
+                <a:sym typeface="Noto Sans SC"/>
+              </a:rPr>
+              <a:t>第一句话是：</a:t>
+            </a:r>
+            <a:r>
+              <a:rPr lang="en-US" b="true" i="false" strike="noStrike" u="none" sz="1800">
+                <a:solidFill>
+                  <a:srgbClr val="0D1326"/>
+                </a:solidFill>
+                <a:latin typeface="Noto Sans SC"/>
+                <a:ea typeface="Noto Sans SC"/>
+                <a:cs typeface="Noto Sans SC"/>
+                <a:sym typeface="Noto Sans SC"/>
+              </a:rPr>
+              <a:t>"这个结论怎么来的？那个数据源链接呢？"</a:t>
+            </a:r>
+            <a:r>
+              <a:rPr lang="en-US" b="false" i="false" strike="noStrike" u="none" sz="1800">
+                <a:solidFill>
+                  <a:srgbClr val="475569"/>
+                </a:solidFill>
+                <a:latin typeface="Noto Sans SC"/>
+                <a:ea typeface="Noto Sans SC"/>
+                <a:cs typeface="Noto Sans SC"/>
+                <a:sym typeface="Noto Sans SC"/>
+              </a:rPr>
+              <a:t/>
+            </a:r>
+          </a:p>
+          <a:p>
+            <a:pPr algn="l" marL="0" indent="0">
+              <a:lnSpc>
+                <a:spcPct val="150000"/>
+              </a:lnSpc>
+            </a:pPr>
+            <a:r>
+              <a:rPr lang="en-US" b="false" i="false" strike="noStrike" u="none" sz="1800">
+                <a:solidFill>
+                  <a:srgbClr val="475569"/>
+                </a:solidFill>
+                <a:latin typeface="Noto Sans SC"/>
+                <a:ea typeface="Noto Sans SC"/>
+                <a:cs typeface="Noto Sans SC"/>
+                <a:sym typeface="Noto Sans SC"/>
+              </a:rPr>
+              <a:t>你得翻两百条聊天记录，才能把当时的判断依据找出来。</a:t>
+            </a:r>
+          </a:p>
+        </p:txBody>
+      </p:sp>
+      <p:sp>
+        <p:nvSpPr>
+          <p:cNvPr name="AutoShape 6" id="6"/>
+          <p:cNvSpPr/>
+          <p:nvPr/>
+        </p:nvSpPr>
+        <p:spPr>
+          <a:xfrm rot="0" flipH="false" flipV="false">
+            <a:off x="1016000" y="4826000"/>
+            <a:ext cx="50800" cy="762000"/>
+          </a:xfrm>
+          <a:prstGeom prst="roundRect">
+            <a:avLst>
+              <a:gd name="adj" fmla="val 0"/>
+            </a:avLst>
+          </a:prstGeom>
+          <a:solidFill>
+            <a:srgbClr val="C9302C">
+              <a:alpha val="100000"/>
+            </a:srgbClr>
+          </a:solidFill>
+          <a:ln w="25400" cmpd="sng" cap="flat">
+            <a:noFill/>
+            <a:prstDash val="solid"/>
+            <a:round/>
+          </a:ln>
+        </p:spPr>
+        <p:txBody>
+          <a:bodyPr anchor="ctr" rtlCol="false" anchorCtr="false" vert="horz" wrap="square" lIns="0" rIns="0" tIns="0" bIns="0"/>
+          <a:lstStyle/>
+          <a:p>
+            <a:pPr algn="ctr">
+              <a:defRPr/>
+            </a:pPr>
+            <a:endParaRPr/>
+          </a:p>
+        </p:txBody>
+      </p:sp>
+      <p:sp>
+        <p:nvSpPr>
+          <p:cNvPr name="AutoShape 7" id="7"/>
+          <p:cNvSpPr/>
+          <p:nvPr/>
+        </p:nvSpPr>
+        <p:spPr>
+          <a:xfrm rot="0" flipH="false" flipV="false">
+            <a:off x="1320800" y="4826000"/>
+            <a:ext cx="9906000" cy="762000"/>
+          </a:xfrm>
+          <a:prstGeom prst="rect">
+            <a:avLst/>
+          </a:prstGeom>
+          <a:noFill/>
+          <a:ln w="12700" cmpd="sng" cap="flat">
+            <a:noFill/>
+            <a:prstDash val="solid"/>
+            <a:round/>
+          </a:ln>
+        </p:spPr>
+        <p:txBody>
+          <a:bodyPr anchor="ctr" rtlCol="false" anchorCtr="false" vert="horz" wrap="square" lIns="0" rIns="0" tIns="0" bIns="0"/>
+          <a:lstStyle/>
+          <a:p>
+            <a:pPr algn="l" marL="0" indent="0">
+              <a:lnSpc>
+                <a:spcPct val="133333"/>
+              </a:lnSpc>
+              <a:defRPr/>
+            </a:pPr>
+            <a:r>
+              <a:rPr lang="en-US" b="false" i="false" strike="noStrike" u="none" sz="1700">
+                <a:solidFill>
+                  <a:srgbClr val="0D1326"/>
+                </a:solidFill>
+                <a:latin typeface="Noto Sans SC"/>
+                <a:ea typeface="Noto Sans SC"/>
+                <a:cs typeface="Noto Sans SC"/>
+                <a:sym typeface="Noto Sans SC"/>
+              </a:rPr>
+              <a:t>这不是你不负责。是现在的工具帮你把活干完了，却</a:t>
+            </a:r>
+            <a:r>
+              <a:rPr lang="en-US" b="true" i="false" strike="noStrike" u="none" sz="1700">
+                <a:solidFill>
+                  <a:srgbClr val="0D1326"/>
+                </a:solidFill>
+                <a:latin typeface="Noto Sans SC"/>
+                <a:ea typeface="Noto Sans SC"/>
+                <a:cs typeface="Noto Sans SC"/>
+                <a:sym typeface="Noto Sans SC"/>
+              </a:rPr>
+              <a:t>没帮你把过程留下来</a:t>
+            </a:r>
+            <a:r>
+              <a:rPr lang="en-US" b="false" i="false" strike="noStrike" u="none" sz="1700">
+                <a:solidFill>
+                  <a:srgbClr val="0D1326"/>
+                </a:solidFill>
+                <a:latin typeface="Noto Sans SC"/>
+                <a:ea typeface="Noto Sans SC"/>
+                <a:cs typeface="Noto Sans SC"/>
+                <a:sym typeface="Noto Sans SC"/>
+              </a:rPr>
+              <a:t>。</a:t>
+            </a:r>
+            <a:endParaRPr lang="en-US" sz="1100"/>
+          </a:p>
+        </p:txBody>
+      </p:sp>
+    </p:spTree>
+  </p:cSld>
+  <p:clrMapOvr>
+    <a:masterClrMapping/>
+  </p:clrMapOvr>
+</p:sld>
+</file>
+
+<file path=ppt/slides/slide20.xml><?xml version="1.0" encoding="utf-8"?>
 <p:sld xmlns:p="http://schemas.openxmlformats.org/presentationml/2006/main" xmlns:a="http://schemas.openxmlformats.org/drawingml/2006/main">
   <p:cSld>
     <p:bg>
@@ -25560,1029 +26847,6 @@
 </p:sld>
 </file>
 
-<file path=ppt/slides/slide2.xml><?xml version="1.0" encoding="utf-8"?>
-<p:sld xmlns:p="http://schemas.openxmlformats.org/presentationml/2006/main" xmlns:a="http://schemas.openxmlformats.org/drawingml/2006/main">
-  <p:cSld>
-    <p:bg>
-      <p:bgPr>
-        <a:solidFill>
-          <a:srgbClr val="FFFFFF">
-            <a:alpha val="100000"/>
-          </a:srgbClr>
-        </a:solidFill>
-      </p:bgPr>
-    </p:bg>
-    <p:spTree>
-      <p:nvGrpSpPr>
-        <p:cNvPr id="1" name=""/>
-        <p:cNvGrpSpPr/>
-        <p:nvPr/>
-      </p:nvGrpSpPr>
-      <p:grpSpPr>
-        <a:xfrm>
-          <a:off x="0" y="0"/>
-          <a:ext cx="0" cy="0"/>
-          <a:chOff x="0" y="0"/>
-          <a:chExt cx="0" cy="0"/>
-        </a:xfrm>
-      </p:grpSpPr>
-      <p:sp>
-        <p:nvSpPr>
-          <p:cNvPr name="AutoShape 2" id="2"/>
-          <p:cNvSpPr/>
-          <p:nvPr/>
-        </p:nvSpPr>
-        <p:spPr>
-          <a:xfrm rot="0" flipH="false" flipV="false">
-            <a:off x="1016000" y="762000"/>
-            <a:ext cx="5080000" cy="254000"/>
-          </a:xfrm>
-          <a:prstGeom prst="rect">
-            <a:avLst/>
-          </a:prstGeom>
-          <a:noFill/>
-          <a:ln w="12700" cmpd="sng" cap="flat">
-            <a:noFill/>
-            <a:prstDash val="solid"/>
-            <a:round/>
-          </a:ln>
-        </p:spPr>
-        <p:txBody>
-          <a:bodyPr anchor="ctr" rtlCol="false" anchorCtr="false" vert="horz" wrap="square" lIns="0" rIns="0" tIns="0" bIns="0"/>
-          <a:lstStyle/>
-          <a:p>
-            <a:pPr algn="l" marL="0" indent="0">
-              <a:lnSpc>
-                <a:spcPct val="125000"/>
-              </a:lnSpc>
-              <a:defRPr/>
-            </a:pPr>
-            <a:r>
-              <a:rPr lang="en-US" b="false" i="false" strike="noStrike" u="none" sz="1100">
-                <a:solidFill>
-                  <a:srgbClr val="94A3B8"/>
-                </a:solidFill>
-                <a:latin typeface="Noto Sans SC"/>
-                <a:ea typeface="Noto Sans SC"/>
-                <a:cs typeface="Noto Sans SC"/>
-                <a:sym typeface="Noto Sans SC"/>
-              </a:rPr>
-              <a:t>01 · 开场</a:t>
-            </a:r>
-            <a:endParaRPr lang="en-US" sz="1100"/>
-          </a:p>
-        </p:txBody>
-      </p:sp>
-      <p:sp>
-        <p:nvSpPr>
-          <p:cNvPr name="AutoShape 3" id="3"/>
-          <p:cNvSpPr/>
-          <p:nvPr/>
-        </p:nvSpPr>
-        <p:spPr>
-          <a:xfrm rot="0" flipH="false" flipV="false">
-            <a:off x="1016000" y="1206500"/>
-            <a:ext cx="10160000" cy="635000"/>
-          </a:xfrm>
-          <a:prstGeom prst="rect">
-            <a:avLst/>
-          </a:prstGeom>
-          <a:noFill/>
-          <a:ln w="12700" cmpd="sng" cap="flat">
-            <a:noFill/>
-            <a:prstDash val="solid"/>
-            <a:round/>
-          </a:ln>
-        </p:spPr>
-        <p:txBody>
-          <a:bodyPr anchor="ctr" rtlCol="false" anchorCtr="false" vert="horz" wrap="square" lIns="0" rIns="0" tIns="0" bIns="0"/>
-          <a:lstStyle/>
-          <a:p>
-            <a:pPr algn="l" marL="0" indent="0">
-              <a:lnSpc>
-                <a:spcPct val="125000"/>
-              </a:lnSpc>
-              <a:defRPr/>
-            </a:pPr>
-            <a:r>
-              <a:rPr lang="en-US" b="true" i="false" strike="noStrike" u="none" sz="3200">
-                <a:solidFill>
-                  <a:srgbClr val="0D1326"/>
-                </a:solidFill>
-                <a:latin typeface="Noto Sans SC"/>
-                <a:ea typeface="Noto Sans SC"/>
-                <a:cs typeface="Noto Sans SC"/>
-                <a:sym typeface="Noto Sans SC"/>
-              </a:rPr>
-              <a:t>你让 AI 做的东西，同事接得住吗？</a:t>
-            </a:r>
-            <a:endParaRPr lang="en-US" sz="1100"/>
-          </a:p>
-        </p:txBody>
-      </p:sp>
-      <p:cxnSp>
-        <p:nvCxnSpPr>
-          <p:cNvPr name="Connector 4" id="4"/>
-          <p:cNvCxnSpPr/>
-          <p:nvPr/>
-        </p:nvCxnSpPr>
-        <p:spPr>
-          <a:xfrm rot="-4297" flipH="false" flipV="false">
-            <a:off x="1016004" y="2152650"/>
-            <a:ext cx="10160008" cy="12700"/>
-          </a:xfrm>
-          <a:prstGeom prst="straightConnector1">
-            <a:avLst/>
-          </a:prstGeom>
-          <a:solidFill>
-            <a:srgbClr val="DEE0E3">
-              <a:alpha val="100000"/>
-            </a:srgbClr>
-          </a:solidFill>
-          <a:ln w="12700" cmpd="sng" cap="flat">
-            <a:solidFill>
-              <a:srgbClr val="E5E7EB">
-                <a:alpha val="100000"/>
-              </a:srgbClr>
-            </a:solidFill>
-            <a:prstDash val="solid"/>
-            <a:round/>
-            <a:headEnd type="none" w="med" len="med"/>
-            <a:tailEnd type="none" w="med" len="med"/>
-          </a:ln>
-        </p:spPr>
-      </p:cxnSp>
-      <p:sp>
-        <p:nvSpPr>
-          <p:cNvPr name="AutoShape 5" id="5"/>
-          <p:cNvSpPr/>
-          <p:nvPr/>
-        </p:nvSpPr>
-        <p:spPr>
-          <a:xfrm rot="0" flipH="false" flipV="false">
-            <a:off x="1016000" y="2540000"/>
-            <a:ext cx="10160000" cy="1524000"/>
-          </a:xfrm>
-          <a:prstGeom prst="rect">
-            <a:avLst/>
-          </a:prstGeom>
-          <a:noFill/>
-          <a:ln w="12700" cmpd="sng" cap="flat">
-            <a:noFill/>
-            <a:prstDash val="solid"/>
-            <a:round/>
-          </a:ln>
-        </p:spPr>
-        <p:txBody>
-          <a:bodyPr anchor="ctr" rtlCol="false" anchorCtr="false" vert="horz" wrap="square" lIns="0" rIns="0" tIns="0" bIns="0"/>
-          <a:lstStyle/>
-          <a:p>
-            <a:pPr algn="l" marL="0" indent="0">
-              <a:lnSpc>
-                <a:spcPct val="150000"/>
-              </a:lnSpc>
-              <a:defRPr/>
-            </a:pPr>
-            <a:r>
-              <a:rPr lang="en-US" b="false" i="false" strike="noStrike" u="none" sz="1800">
-                <a:solidFill>
-                  <a:srgbClr val="475569"/>
-                </a:solidFill>
-                <a:latin typeface="Noto Sans SC"/>
-                <a:ea typeface="Noto Sans SC"/>
-                <a:cs typeface="Noto Sans SC"/>
-                <a:sym typeface="Noto Sans SC"/>
-              </a:rPr>
-              <a:t>你昨天让 AI 帮你做了一下午竞品调研，今天同事接手，</a:t>
-            </a:r>
-            <a:endParaRPr lang="en-US" sz="1100"/>
-          </a:p>
-          <a:p>
-            <a:pPr algn="l" marL="0" indent="0">
-              <a:lnSpc>
-                <a:spcPct val="150000"/>
-              </a:lnSpc>
-            </a:pPr>
-            <a:r>
-              <a:rPr lang="en-US" b="false" i="false" strike="noStrike" u="none" sz="1800">
-                <a:solidFill>
-                  <a:srgbClr val="475569"/>
-                </a:solidFill>
-                <a:latin typeface="Noto Sans SC"/>
-                <a:ea typeface="Noto Sans SC"/>
-                <a:cs typeface="Noto Sans SC"/>
-                <a:sym typeface="Noto Sans SC"/>
-              </a:rPr>
-              <a:t>第一句话是：</a:t>
-            </a:r>
-            <a:r>
-              <a:rPr lang="en-US" b="true" i="false" strike="noStrike" u="none" sz="1800">
-                <a:solidFill>
-                  <a:srgbClr val="0D1326"/>
-                </a:solidFill>
-                <a:latin typeface="Noto Sans SC"/>
-                <a:ea typeface="Noto Sans SC"/>
-                <a:cs typeface="Noto Sans SC"/>
-                <a:sym typeface="Noto Sans SC"/>
-              </a:rPr>
-              <a:t>"这个结论怎么来的？那个数据源链接呢？"</a:t>
-            </a:r>
-            <a:r>
-              <a:rPr lang="en-US" b="false" i="false" strike="noStrike" u="none" sz="1800">
-                <a:solidFill>
-                  <a:srgbClr val="475569"/>
-                </a:solidFill>
-                <a:latin typeface="Noto Sans SC"/>
-                <a:ea typeface="Noto Sans SC"/>
-                <a:cs typeface="Noto Sans SC"/>
-                <a:sym typeface="Noto Sans SC"/>
-              </a:rPr>
-              <a:t/>
-            </a:r>
-          </a:p>
-          <a:p>
-            <a:pPr algn="l" marL="0" indent="0">
-              <a:lnSpc>
-                <a:spcPct val="150000"/>
-              </a:lnSpc>
-            </a:pPr>
-            <a:r>
-              <a:rPr lang="en-US" b="false" i="false" strike="noStrike" u="none" sz="1800">
-                <a:solidFill>
-                  <a:srgbClr val="475569"/>
-                </a:solidFill>
-                <a:latin typeface="Noto Sans SC"/>
-                <a:ea typeface="Noto Sans SC"/>
-                <a:cs typeface="Noto Sans SC"/>
-                <a:sym typeface="Noto Sans SC"/>
-              </a:rPr>
-              <a:t>你得翻两百条聊天记录，才能把当时的判断依据找出来。</a:t>
-            </a:r>
-          </a:p>
-        </p:txBody>
-      </p:sp>
-      <p:sp>
-        <p:nvSpPr>
-          <p:cNvPr name="AutoShape 6" id="6"/>
-          <p:cNvSpPr/>
-          <p:nvPr/>
-        </p:nvSpPr>
-        <p:spPr>
-          <a:xfrm rot="0" flipH="false" flipV="false">
-            <a:off x="1016000" y="4826000"/>
-            <a:ext cx="50800" cy="762000"/>
-          </a:xfrm>
-          <a:prstGeom prst="roundRect">
-            <a:avLst>
-              <a:gd name="adj" fmla="val 0"/>
-            </a:avLst>
-          </a:prstGeom>
-          <a:solidFill>
-            <a:srgbClr val="C9302C">
-              <a:alpha val="100000"/>
-            </a:srgbClr>
-          </a:solidFill>
-          <a:ln w="25400" cmpd="sng" cap="flat">
-            <a:noFill/>
-            <a:prstDash val="solid"/>
-            <a:round/>
-          </a:ln>
-        </p:spPr>
-        <p:txBody>
-          <a:bodyPr anchor="ctr" rtlCol="false" anchorCtr="false" vert="horz" wrap="square" lIns="0" rIns="0" tIns="0" bIns="0"/>
-          <a:lstStyle/>
-          <a:p>
-            <a:pPr algn="ctr">
-              <a:defRPr/>
-            </a:pPr>
-            <a:endParaRPr/>
-          </a:p>
-        </p:txBody>
-      </p:sp>
-      <p:sp>
-        <p:nvSpPr>
-          <p:cNvPr name="AutoShape 7" id="7"/>
-          <p:cNvSpPr/>
-          <p:nvPr/>
-        </p:nvSpPr>
-        <p:spPr>
-          <a:xfrm rot="0" flipH="false" flipV="false">
-            <a:off x="1320800" y="4826000"/>
-            <a:ext cx="9906000" cy="762000"/>
-          </a:xfrm>
-          <a:prstGeom prst="rect">
-            <a:avLst/>
-          </a:prstGeom>
-          <a:noFill/>
-          <a:ln w="12700" cmpd="sng" cap="flat">
-            <a:noFill/>
-            <a:prstDash val="solid"/>
-            <a:round/>
-          </a:ln>
-        </p:spPr>
-        <p:txBody>
-          <a:bodyPr anchor="ctr" rtlCol="false" anchorCtr="false" vert="horz" wrap="square" lIns="0" rIns="0" tIns="0" bIns="0"/>
-          <a:lstStyle/>
-          <a:p>
-            <a:pPr algn="l" marL="0" indent="0">
-              <a:lnSpc>
-                <a:spcPct val="133333"/>
-              </a:lnSpc>
-              <a:defRPr/>
-            </a:pPr>
-            <a:r>
-              <a:rPr lang="en-US" b="false" i="false" strike="noStrike" u="none" sz="1700">
-                <a:solidFill>
-                  <a:srgbClr val="0D1326"/>
-                </a:solidFill>
-                <a:latin typeface="Noto Sans SC"/>
-                <a:ea typeface="Noto Sans SC"/>
-                <a:cs typeface="Noto Sans SC"/>
-                <a:sym typeface="Noto Sans SC"/>
-              </a:rPr>
-              <a:t>这不是你不负责。是现在的工具帮你把活干完了，却</a:t>
-            </a:r>
-            <a:r>
-              <a:rPr lang="en-US" b="true" i="false" strike="noStrike" u="none" sz="1700">
-                <a:solidFill>
-                  <a:srgbClr val="0D1326"/>
-                </a:solidFill>
-                <a:latin typeface="Noto Sans SC"/>
-                <a:ea typeface="Noto Sans SC"/>
-                <a:cs typeface="Noto Sans SC"/>
-                <a:sym typeface="Noto Sans SC"/>
-              </a:rPr>
-              <a:t>没帮你把过程留下来</a:t>
-            </a:r>
-            <a:r>
-              <a:rPr lang="en-US" b="false" i="false" strike="noStrike" u="none" sz="1700">
-                <a:solidFill>
-                  <a:srgbClr val="0D1326"/>
-                </a:solidFill>
-                <a:latin typeface="Noto Sans SC"/>
-                <a:ea typeface="Noto Sans SC"/>
-                <a:cs typeface="Noto Sans SC"/>
-                <a:sym typeface="Noto Sans SC"/>
-              </a:rPr>
-              <a:t>。</a:t>
-            </a:r>
-            <a:endParaRPr lang="en-US" sz="1100"/>
-          </a:p>
-        </p:txBody>
-      </p:sp>
-    </p:spTree>
-  </p:cSld>
-  <p:clrMapOvr>
-    <a:masterClrMapping/>
-  </p:clrMapOvr>
-</p:sld>
-</file>
-
-<file path=ppt/slides/slide20.xml><?xml version="1.0" encoding="utf-8"?>
-<p:sld xmlns:p="http://schemas.openxmlformats.org/presentationml/2006/main" xmlns:a="http://schemas.openxmlformats.org/drawingml/2006/main">
-  <p:cSld>
-    <p:bg>
-      <p:bgPr>
-        <a:solidFill>
-          <a:srgbClr val="FFFFFF">
-            <a:alpha val="100000"/>
-          </a:srgbClr>
-        </a:solidFill>
-      </p:bgPr>
-    </p:bg>
-    <p:spTree>
-      <p:nvGrpSpPr>
-        <p:cNvPr id="1" name=""/>
-        <p:cNvGrpSpPr/>
-        <p:nvPr/>
-      </p:nvGrpSpPr>
-      <p:grpSpPr>
-        <a:xfrm>
-          <a:off x="0" y="0"/>
-          <a:ext cx="0" cy="0"/>
-          <a:chOff x="0" y="0"/>
-          <a:chExt cx="0" cy="0"/>
-        </a:xfrm>
-      </p:grpSpPr>
-      <p:sp>
-        <p:nvSpPr>
-          <p:cNvPr name="AutoShape 2" id="2"/>
-          <p:cNvSpPr/>
-          <p:nvPr/>
-        </p:nvSpPr>
-        <p:spPr>
-          <a:xfrm rot="0" flipH="false" flipV="false">
-            <a:off x="1016000" y="762000"/>
-            <a:ext cx="5080000" cy="254000"/>
-          </a:xfrm>
-          <a:prstGeom prst="rect">
-            <a:avLst/>
-          </a:prstGeom>
-          <a:noFill/>
-          <a:ln w="12700" cmpd="sng" cap="flat">
-            <a:noFill/>
-            <a:prstDash val="solid"/>
-            <a:round/>
-          </a:ln>
-        </p:spPr>
-        <p:txBody>
-          <a:bodyPr anchor="ctr" rtlCol="false" anchorCtr="false" vert="horz" wrap="square" lIns="0" rIns="0" tIns="0" bIns="0"/>
-          <a:lstStyle/>
-          <a:p>
-            <a:pPr algn="l" marL="0" indent="0">
-              <a:lnSpc>
-                <a:spcPct val="125000"/>
-              </a:lnSpc>
-              <a:defRPr/>
-            </a:pPr>
-            <a:r>
-              <a:rPr lang="en-US" b="false" i="false" strike="noStrike" u="none" sz="1100">
-                <a:solidFill>
-                  <a:srgbClr val="94A3B8"/>
-                </a:solidFill>
-                <a:latin typeface="Noto Sans SC"/>
-                <a:ea typeface="Noto Sans SC"/>
-                <a:cs typeface="Noto Sans SC"/>
-                <a:sym typeface="Noto Sans SC"/>
-              </a:rPr>
-              <a:t>05 · 合流</a:t>
-            </a:r>
-            <a:endParaRPr lang="en-US" sz="1100"/>
-          </a:p>
-        </p:txBody>
-      </p:sp>
-      <p:sp>
-        <p:nvSpPr>
-          <p:cNvPr name="AutoShape 3" id="3"/>
-          <p:cNvSpPr/>
-          <p:nvPr/>
-        </p:nvSpPr>
-        <p:spPr>
-          <a:xfrm rot="0" flipH="false" flipV="false">
-            <a:off x="1016000" y="1206500"/>
-            <a:ext cx="10160000" cy="508000"/>
-          </a:xfrm>
-          <a:prstGeom prst="rect">
-            <a:avLst/>
-          </a:prstGeom>
-          <a:noFill/>
-          <a:ln w="12700" cmpd="sng" cap="flat">
-            <a:noFill/>
-            <a:prstDash val="solid"/>
-            <a:round/>
-          </a:ln>
-        </p:spPr>
-        <p:txBody>
-          <a:bodyPr anchor="ctr" rtlCol="false" anchorCtr="false" vert="horz" wrap="square" lIns="0" rIns="0" tIns="0" bIns="0"/>
-          <a:lstStyle/>
-          <a:p>
-            <a:pPr algn="l" marL="0" indent="0">
-              <a:lnSpc>
-                <a:spcPct val="125000"/>
-              </a:lnSpc>
-              <a:defRPr/>
-            </a:pPr>
-            <a:r>
-              <a:rPr lang="en-US" b="true" i="false" strike="noStrike" u="none" sz="2800">
-                <a:solidFill>
-                  <a:srgbClr val="0D1326"/>
-                </a:solidFill>
-                <a:latin typeface="Noto Sans SC"/>
-                <a:ea typeface="Noto Sans SC"/>
-                <a:cs typeface="Noto Sans SC"/>
-                <a:sym typeface="Noto Sans SC"/>
-              </a:rPr>
-              <a:t>两条路，填的是同一道沟</a:t>
-            </a:r>
-            <a:endParaRPr lang="en-US" sz="1100"/>
-          </a:p>
-        </p:txBody>
-      </p:sp>
-      <p:sp>
-        <p:nvSpPr>
-          <p:cNvPr name="AutoShape 4" id="4"/>
-          <p:cNvSpPr/>
-          <p:nvPr/>
-        </p:nvSpPr>
-        <p:spPr>
-          <a:xfrm rot="0" flipH="false" flipV="false">
-            <a:off x="1016000" y="2286000"/>
-            <a:ext cx="4318000" cy="1905000"/>
-          </a:xfrm>
-          <a:prstGeom prst="roundRect">
-            <a:avLst>
-              <a:gd name="adj" fmla="val 0"/>
-            </a:avLst>
-          </a:prstGeom>
-          <a:solidFill>
-            <a:srgbClr val="F1F5F9">
-              <a:alpha val="100000"/>
-            </a:srgbClr>
-          </a:solidFill>
-          <a:ln w="25400" cmpd="sng" cap="flat">
-            <a:noFill/>
-            <a:prstDash val="solid"/>
-            <a:round/>
-          </a:ln>
-        </p:spPr>
-        <p:txBody>
-          <a:bodyPr anchor="ctr" rtlCol="false" anchorCtr="false" vert="horz" wrap="square" lIns="0" rIns="0" tIns="0" bIns="0"/>
-          <a:lstStyle/>
-          <a:p>
-            <a:pPr algn="ctr">
-              <a:defRPr/>
-            </a:pPr>
-            <a:endParaRPr/>
-          </a:p>
-        </p:txBody>
-      </p:sp>
-      <p:sp>
-        <p:nvSpPr>
-          <p:cNvPr name="AutoShape 5" id="5"/>
-          <p:cNvSpPr/>
-          <p:nvPr/>
-        </p:nvSpPr>
-        <p:spPr>
-          <a:xfrm rot="0" flipH="false" flipV="false">
-            <a:off x="1270000" y="2514600"/>
-            <a:ext cx="3810000" cy="304800"/>
-          </a:xfrm>
-          <a:prstGeom prst="rect">
-            <a:avLst/>
-          </a:prstGeom>
-          <a:noFill/>
-          <a:ln w="12700" cmpd="sng" cap="flat">
-            <a:noFill/>
-            <a:prstDash val="solid"/>
-            <a:round/>
-          </a:ln>
-        </p:spPr>
-        <p:txBody>
-          <a:bodyPr anchor="ctr" rtlCol="false" anchorCtr="false" vert="horz" wrap="square" lIns="0" rIns="0" tIns="0" bIns="0"/>
-          <a:lstStyle/>
-          <a:p>
-            <a:pPr algn="l" marL="0" indent="0">
-              <a:lnSpc>
-                <a:spcPct val="125000"/>
-              </a:lnSpc>
-              <a:defRPr/>
-            </a:pPr>
-            <a:r>
-              <a:rPr lang="en-US" b="true" i="false" strike="noStrike" u="none" sz="1500">
-                <a:solidFill>
-                  <a:srgbClr val="0D1326"/>
-                </a:solidFill>
-                <a:latin typeface="Noto Sans SC"/>
-                <a:ea typeface="Noto Sans SC"/>
-                <a:cs typeface="Noto Sans SC"/>
-                <a:sym typeface="Noto Sans SC"/>
-              </a:rPr>
-              <a:t>多智能体协同</a:t>
-            </a:r>
-            <a:endParaRPr lang="en-US" sz="1100"/>
-          </a:p>
-        </p:txBody>
-      </p:sp>
-      <p:sp>
-        <p:nvSpPr>
-          <p:cNvPr name="AutoShape 6" id="6"/>
-          <p:cNvSpPr/>
-          <p:nvPr/>
-        </p:nvSpPr>
-        <p:spPr>
-          <a:xfrm rot="0" flipH="false" flipV="false">
-            <a:off x="1270000" y="2921000"/>
-            <a:ext cx="3810000" cy="1143000"/>
-          </a:xfrm>
-          <a:prstGeom prst="rect">
-            <a:avLst/>
-          </a:prstGeom>
-          <a:noFill/>
-          <a:ln w="12700" cmpd="sng" cap="flat">
-            <a:noFill/>
-            <a:prstDash val="solid"/>
-            <a:round/>
-          </a:ln>
-        </p:spPr>
-        <p:txBody>
-          <a:bodyPr anchor="ctr" rtlCol="false" anchorCtr="false" vert="horz" wrap="square" lIns="0" rIns="0" tIns="0" bIns="0"/>
-          <a:lstStyle/>
-          <a:p>
-            <a:pPr algn="l" marL="0" indent="0">
-              <a:lnSpc>
-                <a:spcPct val="141666"/>
-              </a:lnSpc>
-              <a:defRPr/>
-            </a:pPr>
-            <a:r>
-              <a:rPr lang="en-US" b="false" i="false" strike="noStrike" u="none" sz="1300">
-                <a:solidFill>
-                  <a:srgbClr val="475569"/>
-                </a:solidFill>
-                <a:latin typeface="Noto Sans SC"/>
-                <a:ea typeface="Noto Sans SC"/>
-                <a:cs typeface="Noto Sans SC"/>
-                <a:sym typeface="Noto Sans SC"/>
-              </a:rPr>
-              <a:t>技术界的桥：</a:t>
-            </a:r>
-            <a:endParaRPr lang="en-US" sz="1100"/>
-          </a:p>
-          <a:p>
-            <a:pPr algn="l" marL="0" indent="0">
-              <a:lnSpc>
-                <a:spcPct val="141666"/>
-              </a:lnSpc>
-            </a:pPr>
-            <a:r>
-              <a:rPr lang="en-US" b="false" i="false" strike="noStrike" u="none" sz="1300">
-                <a:solidFill>
-                  <a:srgbClr val="475569"/>
-                </a:solidFill>
-                <a:latin typeface="Noto Sans SC"/>
-                <a:ea typeface="Noto Sans SC"/>
-                <a:cs typeface="Noto Sans SC"/>
-                <a:sym typeface="Noto Sans SC"/>
-              </a:rPr>
-              <a:t>保护 agent 之间的</a:t>
-            </a:r>
-            <a:r>
-              <a:rPr lang="en-US" b="true" i="false" strike="noStrike" u="none" sz="1300">
-                <a:solidFill>
-                  <a:srgbClr val="0D1326"/>
-                </a:solidFill>
-                <a:latin typeface="Noto Sans SC"/>
-                <a:ea typeface="Noto Sans SC"/>
-                <a:cs typeface="Noto Sans SC"/>
-                <a:sym typeface="Noto Sans SC"/>
-              </a:rPr>
-              <a:t>独立视角</a:t>
-            </a:r>
-            <a:r>
-              <a:rPr lang="en-US" b="false" i="false" strike="noStrike" u="none" sz="1300">
-                <a:solidFill>
-                  <a:srgbClr val="475569"/>
-                </a:solidFill>
-                <a:latin typeface="Noto Sans SC"/>
-                <a:ea typeface="Noto Sans SC"/>
-                <a:cs typeface="Noto Sans SC"/>
-                <a:sym typeface="Noto Sans SC"/>
-              </a:rPr>
-              <a:t>，不被层级汇报压平</a:t>
-            </a:r>
-          </a:p>
-        </p:txBody>
-      </p:sp>
-      <p:sp>
-        <p:nvSpPr>
-          <p:cNvPr name="AutoShape 7" id="7"/>
-          <p:cNvSpPr/>
-          <p:nvPr/>
-        </p:nvSpPr>
-        <p:spPr>
-          <a:xfrm rot="0" flipH="false" flipV="false">
-            <a:off x="6858000" y="2286000"/>
-            <a:ext cx="4318000" cy="1905000"/>
-          </a:xfrm>
-          <a:prstGeom prst="roundRect">
-            <a:avLst>
-              <a:gd name="adj" fmla="val 0"/>
-            </a:avLst>
-          </a:prstGeom>
-          <a:solidFill>
-            <a:srgbClr val="C9302C">
-              <a:alpha val="8000"/>
-            </a:srgbClr>
-          </a:solidFill>
-          <a:ln w="25400" cmpd="sng" cap="flat">
-            <a:noFill/>
-            <a:prstDash val="solid"/>
-            <a:round/>
-          </a:ln>
-        </p:spPr>
-        <p:txBody>
-          <a:bodyPr anchor="ctr" rtlCol="false" anchorCtr="false" vert="horz" wrap="square" lIns="0" rIns="0" tIns="0" bIns="0"/>
-          <a:lstStyle/>
-          <a:p>
-            <a:pPr algn="ctr">
-              <a:defRPr/>
-            </a:pPr>
-            <a:endParaRPr/>
-          </a:p>
-        </p:txBody>
-      </p:sp>
-      <p:sp>
-        <p:nvSpPr>
-          <p:cNvPr name="AutoShape 8" id="8"/>
-          <p:cNvSpPr/>
-          <p:nvPr/>
-        </p:nvSpPr>
-        <p:spPr>
-          <a:xfrm rot="0" flipH="false" flipV="false">
-            <a:off x="7112000" y="2514600"/>
-            <a:ext cx="3810000" cy="304800"/>
-          </a:xfrm>
-          <a:prstGeom prst="rect">
-            <a:avLst/>
-          </a:prstGeom>
-          <a:noFill/>
-          <a:ln w="12700" cmpd="sng" cap="flat">
-            <a:noFill/>
-            <a:prstDash val="solid"/>
-            <a:round/>
-          </a:ln>
-        </p:spPr>
-        <p:txBody>
-          <a:bodyPr anchor="ctr" rtlCol="false" anchorCtr="false" vert="horz" wrap="square" lIns="0" rIns="0" tIns="0" bIns="0"/>
-          <a:lstStyle/>
-          <a:p>
-            <a:pPr algn="l" marL="0" indent="0">
-              <a:lnSpc>
-                <a:spcPct val="125000"/>
-              </a:lnSpc>
-              <a:defRPr/>
-            </a:pPr>
-            <a:r>
-              <a:rPr lang="en-US" b="true" i="false" strike="noStrike" u="none" sz="1500">
-                <a:solidFill>
-                  <a:srgbClr val="0D1326"/>
-                </a:solidFill>
-                <a:latin typeface="Noto Sans SC"/>
-                <a:ea typeface="Noto Sans SC"/>
-                <a:cs typeface="Noto Sans SC"/>
-                <a:sym typeface="Noto Sans SC"/>
-              </a:rPr>
-              <a:t>TabTin</a:t>
-            </a:r>
-            <a:endParaRPr lang="en-US" sz="1100"/>
-          </a:p>
-        </p:txBody>
-      </p:sp>
-      <p:sp>
-        <p:nvSpPr>
-          <p:cNvPr name="AutoShape 9" id="9"/>
-          <p:cNvSpPr/>
-          <p:nvPr/>
-        </p:nvSpPr>
-        <p:spPr>
-          <a:xfrm rot="0" flipH="false" flipV="false">
-            <a:off x="7112000" y="2921000"/>
-            <a:ext cx="3810000" cy="1143000"/>
-          </a:xfrm>
-          <a:prstGeom prst="rect">
-            <a:avLst/>
-          </a:prstGeom>
-          <a:noFill/>
-          <a:ln w="12700" cmpd="sng" cap="flat">
-            <a:noFill/>
-            <a:prstDash val="solid"/>
-            <a:round/>
-          </a:ln>
-        </p:spPr>
-        <p:txBody>
-          <a:bodyPr anchor="ctr" rtlCol="false" anchorCtr="false" vert="horz" wrap="square" lIns="0" rIns="0" tIns="0" bIns="0"/>
-          <a:lstStyle/>
-          <a:p>
-            <a:pPr algn="l" marL="0" indent="0">
-              <a:lnSpc>
-                <a:spcPct val="141666"/>
-              </a:lnSpc>
-              <a:defRPr/>
-            </a:pPr>
-            <a:r>
-              <a:rPr lang="en-US" b="false" i="false" strike="noStrike" u="none" sz="1300">
-                <a:solidFill>
-                  <a:srgbClr val="475569"/>
-                </a:solidFill>
-                <a:latin typeface="Noto Sans SC"/>
-                <a:ea typeface="Noto Sans SC"/>
-                <a:cs typeface="Noto Sans SC"/>
-                <a:sym typeface="Noto Sans SC"/>
-              </a:rPr>
-              <a:t>产品界的桥：</a:t>
-            </a:r>
-            <a:endParaRPr lang="en-US" sz="1100"/>
-          </a:p>
-          <a:p>
-            <a:pPr algn="l" marL="0" indent="0">
-              <a:lnSpc>
-                <a:spcPct val="141666"/>
-              </a:lnSpc>
-            </a:pPr>
-            <a:r>
-              <a:rPr lang="en-US" b="false" i="false" strike="noStrike" u="none" sz="1300">
-                <a:solidFill>
-                  <a:srgbClr val="475569"/>
-                </a:solidFill>
-                <a:latin typeface="Noto Sans SC"/>
-                <a:ea typeface="Noto Sans SC"/>
-                <a:cs typeface="Noto Sans SC"/>
-                <a:sym typeface="Noto Sans SC"/>
-              </a:rPr>
-              <a:t>保护人之间的</a:t>
-            </a:r>
-            <a:r>
-              <a:rPr lang="en-US" b="true" i="false" strike="noStrike" u="none" sz="1300">
-                <a:solidFill>
-                  <a:srgbClr val="0D1326"/>
-                </a:solidFill>
-                <a:latin typeface="Noto Sans SC"/>
-                <a:ea typeface="Noto Sans SC"/>
-                <a:cs typeface="Noto Sans SC"/>
-                <a:sym typeface="Noto Sans SC"/>
-              </a:rPr>
-              <a:t>工作上下文</a:t>
-            </a:r>
-            <a:r>
-              <a:rPr lang="en-US" b="false" i="false" strike="noStrike" u="none" sz="1300">
-                <a:solidFill>
-                  <a:srgbClr val="475569"/>
-                </a:solidFill>
-                <a:latin typeface="Noto Sans SC"/>
-                <a:ea typeface="Noto Sans SC"/>
-                <a:cs typeface="Noto Sans SC"/>
-                <a:sym typeface="Noto Sans SC"/>
-              </a:rPr>
-              <a:t>，不被交接丢掉</a:t>
-            </a:r>
-          </a:p>
-        </p:txBody>
-      </p:sp>
-      <p:sp>
-        <p:nvSpPr>
-          <p:cNvPr name="AutoShape 10" id="10"/>
-          <p:cNvSpPr/>
-          <p:nvPr/>
-        </p:nvSpPr>
-        <p:spPr>
-          <a:xfrm rot="0" flipH="false" flipV="false">
-            <a:off x="5588000" y="2984500"/>
-            <a:ext cx="1016000" cy="508000"/>
-          </a:xfrm>
-          <a:prstGeom prst="rect">
-            <a:avLst/>
-          </a:prstGeom>
-          <a:noFill/>
-          <a:ln w="12700" cmpd="sng" cap="flat">
-            <a:noFill/>
-            <a:prstDash val="solid"/>
-            <a:round/>
-          </a:ln>
-        </p:spPr>
-        <p:txBody>
-          <a:bodyPr anchor="ctr" rtlCol="false" anchorCtr="false" vert="horz" wrap="square" lIns="0" rIns="0" tIns="0" bIns="0"/>
-          <a:lstStyle/>
-          <a:p>
-            <a:pPr algn="ctr" marL="0" indent="0">
-              <a:lnSpc>
-                <a:spcPct val="125000"/>
-              </a:lnSpc>
-              <a:defRPr/>
-            </a:pPr>
-            <a:r>
-              <a:rPr lang="en-US" b="true" i="false" strike="noStrike" u="none" sz="2800">
-                <a:solidFill>
-                  <a:srgbClr val="94A3B8"/>
-                </a:solidFill>
-                <a:latin typeface="Noto Sans SC"/>
-                <a:ea typeface="Noto Sans SC"/>
-                <a:cs typeface="Noto Sans SC"/>
-                <a:sym typeface="Noto Sans SC"/>
-              </a:rPr>
-              <a:t>+</a:t>
-            </a:r>
-            <a:endParaRPr lang="en-US" sz="1100"/>
-          </a:p>
-        </p:txBody>
-      </p:sp>
-      <p:sp>
-        <p:nvSpPr>
-          <p:cNvPr name="AutoShape 11" id="11"/>
-          <p:cNvSpPr/>
-          <p:nvPr/>
-        </p:nvSpPr>
-        <p:spPr>
-          <a:xfrm rot="0" flipH="false" flipV="false">
-            <a:off x="2286000" y="4699000"/>
-            <a:ext cx="7620000" cy="889000"/>
-          </a:xfrm>
-          <a:prstGeom prst="roundRect">
-            <a:avLst>
-              <a:gd name="adj" fmla="val 0"/>
-            </a:avLst>
-          </a:prstGeom>
-          <a:solidFill>
-            <a:srgbClr val="FFFFFF">
-              <a:alpha val="100000"/>
-            </a:srgbClr>
-          </a:solidFill>
-          <a:ln w="12700" cmpd="sng" cap="flat">
-            <a:solidFill>
-              <a:srgbClr val="0D1326">
-                <a:alpha val="100000"/>
-              </a:srgbClr>
-            </a:solidFill>
-            <a:prstDash val="solid"/>
-            <a:round/>
-          </a:ln>
-        </p:spPr>
-        <p:txBody>
-          <a:bodyPr anchor="ctr" rtlCol="false" anchorCtr="false" vert="horz" wrap="square" lIns="0" rIns="0" tIns="0" bIns="0"/>
-          <a:lstStyle/>
-          <a:p>
-            <a:pPr algn="ctr">
-              <a:defRPr/>
-            </a:pPr>
-            <a:endParaRPr/>
-          </a:p>
-        </p:txBody>
-      </p:sp>
-      <p:sp>
-        <p:nvSpPr>
-          <p:cNvPr name="AutoShape 12" id="12"/>
-          <p:cNvSpPr/>
-          <p:nvPr/>
-        </p:nvSpPr>
-        <p:spPr>
-          <a:xfrm rot="0" flipH="false" flipV="false">
-            <a:off x="2540000" y="4851400"/>
-            <a:ext cx="7112000" cy="635000"/>
-          </a:xfrm>
-          <a:prstGeom prst="rect">
-            <a:avLst/>
-          </a:prstGeom>
-          <a:noFill/>
-          <a:ln w="12700" cmpd="sng" cap="flat">
-            <a:noFill/>
-            <a:prstDash val="solid"/>
-            <a:round/>
-          </a:ln>
-        </p:spPr>
-        <p:txBody>
-          <a:bodyPr anchor="ctr" rtlCol="false" anchorCtr="false" vert="horz" wrap="square" lIns="0" rIns="0" tIns="0" bIns="0"/>
-          <a:lstStyle/>
-          <a:p>
-            <a:pPr algn="ctr" marL="0" indent="0">
-              <a:lnSpc>
-                <a:spcPct val="125000"/>
-              </a:lnSpc>
-              <a:defRPr/>
-            </a:pPr>
-            <a:r>
-              <a:rPr lang="en-US" b="false" i="false" strike="noStrike" u="none" sz="1500">
-                <a:solidFill>
-                  <a:srgbClr val="0D1326"/>
-                </a:solidFill>
-                <a:latin typeface="Noto Sans SC"/>
-                <a:ea typeface="Noto Sans SC"/>
-                <a:cs typeface="Noto Sans SC"/>
-                <a:sym typeface="Noto Sans SC"/>
-              </a:rPr>
-              <a:t>共同的敌人：信息从一个工作主体传到另一个时，</a:t>
-            </a:r>
-            <a:endParaRPr lang="en-US" sz="1100"/>
-          </a:p>
-          <a:p>
-            <a:pPr algn="ctr" marL="0" indent="0">
-              <a:lnSpc>
-                <a:spcPct val="125000"/>
-              </a:lnSpc>
-            </a:pPr>
-            <a:r>
-              <a:rPr lang="en-US" b="false" i="false" strike="noStrike" u="none" sz="1500">
-                <a:solidFill>
-                  <a:srgbClr val="0D1326"/>
-                </a:solidFill>
-                <a:latin typeface="Noto Sans SC"/>
-                <a:ea typeface="Noto Sans SC"/>
-                <a:cs typeface="Noto Sans SC"/>
-                <a:sym typeface="Noto Sans SC"/>
-              </a:rPr>
-              <a:t>在"汇报 / 交接"这一步被压成了</a:t>
-            </a:r>
-            <a:r>
-              <a:rPr lang="en-US" b="true" i="false" strike="noStrike" u="none" sz="1500">
-                <a:solidFill>
-                  <a:srgbClr val="0D1326"/>
-                </a:solidFill>
-                <a:latin typeface="Noto Sans SC"/>
-                <a:ea typeface="Noto Sans SC"/>
-                <a:cs typeface="Noto Sans SC"/>
-                <a:sym typeface="Noto Sans SC"/>
-              </a:rPr>
-              <a:t>有损摘要</a:t>
-            </a:r>
-          </a:p>
-        </p:txBody>
-      </p:sp>
-    </p:spTree>
-  </p:cSld>
-  <p:clrMapOvr>
-    <a:masterClrMapping/>
-  </p:clrMapOvr>
-</p:sld>
-</file>
-
 <file path=ppt/slides/slide21.xml><?xml version="1.0" encoding="utf-8"?>
 <p:sld xmlns:p="http://schemas.openxmlformats.org/presentationml/2006/main" xmlns:a="http://schemas.openxmlformats.org/drawingml/2006/main">
   <p:cSld>
@@ -26650,6 +26914,651 @@
                 <a:cs typeface="Noto Sans SC"/>
                 <a:sym typeface="Noto Sans SC"/>
               </a:rPr>
+              <a:t>05 · 合流</a:t>
+            </a:r>
+            <a:endParaRPr lang="en-US" sz="1100"/>
+          </a:p>
+        </p:txBody>
+      </p:sp>
+      <p:sp>
+        <p:nvSpPr>
+          <p:cNvPr name="AutoShape 3" id="3"/>
+          <p:cNvSpPr/>
+          <p:nvPr/>
+        </p:nvSpPr>
+        <p:spPr>
+          <a:xfrm rot="0" flipH="false" flipV="false">
+            <a:off x="1016000" y="1206500"/>
+            <a:ext cx="10160000" cy="508000"/>
+          </a:xfrm>
+          <a:prstGeom prst="rect">
+            <a:avLst/>
+          </a:prstGeom>
+          <a:noFill/>
+          <a:ln w="12700" cmpd="sng" cap="flat">
+            <a:noFill/>
+            <a:prstDash val="solid"/>
+            <a:round/>
+          </a:ln>
+        </p:spPr>
+        <p:txBody>
+          <a:bodyPr anchor="ctr" rtlCol="false" anchorCtr="false" vert="horz" wrap="square" lIns="0" rIns="0" tIns="0" bIns="0"/>
+          <a:lstStyle/>
+          <a:p>
+            <a:pPr algn="l" marL="0" indent="0">
+              <a:lnSpc>
+                <a:spcPct val="125000"/>
+              </a:lnSpc>
+              <a:defRPr/>
+            </a:pPr>
+            <a:r>
+              <a:rPr lang="en-US" b="true" i="false" strike="noStrike" u="none" sz="2800">
+                <a:solidFill>
+                  <a:srgbClr val="0D1326"/>
+                </a:solidFill>
+                <a:latin typeface="Noto Sans SC"/>
+                <a:ea typeface="Noto Sans SC"/>
+                <a:cs typeface="Noto Sans SC"/>
+                <a:sym typeface="Noto Sans SC"/>
+              </a:rPr>
+              <a:t>两条路，填的是同一道沟</a:t>
+            </a:r>
+            <a:endParaRPr lang="en-US" sz="1100"/>
+          </a:p>
+        </p:txBody>
+      </p:sp>
+      <p:sp>
+        <p:nvSpPr>
+          <p:cNvPr name="AutoShape 4" id="4"/>
+          <p:cNvSpPr/>
+          <p:nvPr/>
+        </p:nvSpPr>
+        <p:spPr>
+          <a:xfrm rot="0" flipH="false" flipV="false">
+            <a:off x="1016000" y="2286000"/>
+            <a:ext cx="4318000" cy="1905000"/>
+          </a:xfrm>
+          <a:prstGeom prst="roundRect">
+            <a:avLst>
+              <a:gd name="adj" fmla="val 0"/>
+            </a:avLst>
+          </a:prstGeom>
+          <a:solidFill>
+            <a:srgbClr val="F1F5F9">
+              <a:alpha val="100000"/>
+            </a:srgbClr>
+          </a:solidFill>
+          <a:ln w="25400" cmpd="sng" cap="flat">
+            <a:noFill/>
+            <a:prstDash val="solid"/>
+            <a:round/>
+          </a:ln>
+        </p:spPr>
+        <p:txBody>
+          <a:bodyPr anchor="ctr" rtlCol="false" anchorCtr="false" vert="horz" wrap="square" lIns="0" rIns="0" tIns="0" bIns="0"/>
+          <a:lstStyle/>
+          <a:p>
+            <a:pPr algn="ctr">
+              <a:defRPr/>
+            </a:pPr>
+            <a:endParaRPr/>
+          </a:p>
+        </p:txBody>
+      </p:sp>
+      <p:sp>
+        <p:nvSpPr>
+          <p:cNvPr name="AutoShape 5" id="5"/>
+          <p:cNvSpPr/>
+          <p:nvPr/>
+        </p:nvSpPr>
+        <p:spPr>
+          <a:xfrm rot="0" flipH="false" flipV="false">
+            <a:off x="1270000" y="2514600"/>
+            <a:ext cx="3810000" cy="304800"/>
+          </a:xfrm>
+          <a:prstGeom prst="rect">
+            <a:avLst/>
+          </a:prstGeom>
+          <a:noFill/>
+          <a:ln w="12700" cmpd="sng" cap="flat">
+            <a:noFill/>
+            <a:prstDash val="solid"/>
+            <a:round/>
+          </a:ln>
+        </p:spPr>
+        <p:txBody>
+          <a:bodyPr anchor="ctr" rtlCol="false" anchorCtr="false" vert="horz" wrap="square" lIns="0" rIns="0" tIns="0" bIns="0"/>
+          <a:lstStyle/>
+          <a:p>
+            <a:pPr algn="l" marL="0" indent="0">
+              <a:lnSpc>
+                <a:spcPct val="125000"/>
+              </a:lnSpc>
+              <a:defRPr/>
+            </a:pPr>
+            <a:r>
+              <a:rPr lang="en-US" b="true" i="false" strike="noStrike" u="none" sz="1500">
+                <a:solidFill>
+                  <a:srgbClr val="0D1326"/>
+                </a:solidFill>
+                <a:latin typeface="Noto Sans SC"/>
+                <a:ea typeface="Noto Sans SC"/>
+                <a:cs typeface="Noto Sans SC"/>
+                <a:sym typeface="Noto Sans SC"/>
+              </a:rPr>
+              <a:t>多智能体协同</a:t>
+            </a:r>
+            <a:endParaRPr lang="en-US" sz="1100"/>
+          </a:p>
+        </p:txBody>
+      </p:sp>
+      <p:sp>
+        <p:nvSpPr>
+          <p:cNvPr name="AutoShape 6" id="6"/>
+          <p:cNvSpPr/>
+          <p:nvPr/>
+        </p:nvSpPr>
+        <p:spPr>
+          <a:xfrm rot="0" flipH="false" flipV="false">
+            <a:off x="1270000" y="2921000"/>
+            <a:ext cx="3810000" cy="1143000"/>
+          </a:xfrm>
+          <a:prstGeom prst="rect">
+            <a:avLst/>
+          </a:prstGeom>
+          <a:noFill/>
+          <a:ln w="12700" cmpd="sng" cap="flat">
+            <a:noFill/>
+            <a:prstDash val="solid"/>
+            <a:round/>
+          </a:ln>
+        </p:spPr>
+        <p:txBody>
+          <a:bodyPr anchor="ctr" rtlCol="false" anchorCtr="false" vert="horz" wrap="square" lIns="0" rIns="0" tIns="0" bIns="0"/>
+          <a:lstStyle/>
+          <a:p>
+            <a:pPr algn="l" marL="0" indent="0">
+              <a:lnSpc>
+                <a:spcPct val="141666"/>
+              </a:lnSpc>
+              <a:defRPr/>
+            </a:pPr>
+            <a:r>
+              <a:rPr lang="en-US" b="false" i="false" strike="noStrike" u="none" sz="1300">
+                <a:solidFill>
+                  <a:srgbClr val="475569"/>
+                </a:solidFill>
+                <a:latin typeface="Noto Sans SC"/>
+                <a:ea typeface="Noto Sans SC"/>
+                <a:cs typeface="Noto Sans SC"/>
+                <a:sym typeface="Noto Sans SC"/>
+              </a:rPr>
+              <a:t>技术界的桥：</a:t>
+            </a:r>
+            <a:endParaRPr lang="en-US" sz="1100"/>
+          </a:p>
+          <a:p>
+            <a:pPr algn="l" marL="0" indent="0">
+              <a:lnSpc>
+                <a:spcPct val="141666"/>
+              </a:lnSpc>
+            </a:pPr>
+            <a:r>
+              <a:rPr lang="en-US" b="false" i="false" strike="noStrike" u="none" sz="1300">
+                <a:solidFill>
+                  <a:srgbClr val="475569"/>
+                </a:solidFill>
+                <a:latin typeface="Noto Sans SC"/>
+                <a:ea typeface="Noto Sans SC"/>
+                <a:cs typeface="Noto Sans SC"/>
+                <a:sym typeface="Noto Sans SC"/>
+              </a:rPr>
+              <a:t>保护 agent 之间的</a:t>
+            </a:r>
+            <a:r>
+              <a:rPr lang="en-US" b="true" i="false" strike="noStrike" u="none" sz="1300">
+                <a:solidFill>
+                  <a:srgbClr val="0D1326"/>
+                </a:solidFill>
+                <a:latin typeface="Noto Sans SC"/>
+                <a:ea typeface="Noto Sans SC"/>
+                <a:cs typeface="Noto Sans SC"/>
+                <a:sym typeface="Noto Sans SC"/>
+              </a:rPr>
+              <a:t>独立视角</a:t>
+            </a:r>
+            <a:r>
+              <a:rPr lang="en-US" b="false" i="false" strike="noStrike" u="none" sz="1300">
+                <a:solidFill>
+                  <a:srgbClr val="475569"/>
+                </a:solidFill>
+                <a:latin typeface="Noto Sans SC"/>
+                <a:ea typeface="Noto Sans SC"/>
+                <a:cs typeface="Noto Sans SC"/>
+                <a:sym typeface="Noto Sans SC"/>
+              </a:rPr>
+              <a:t>，不被层级汇报压平</a:t>
+            </a:r>
+          </a:p>
+        </p:txBody>
+      </p:sp>
+      <p:sp>
+        <p:nvSpPr>
+          <p:cNvPr name="AutoShape 7" id="7"/>
+          <p:cNvSpPr/>
+          <p:nvPr/>
+        </p:nvSpPr>
+        <p:spPr>
+          <a:xfrm rot="0" flipH="false" flipV="false">
+            <a:off x="6858000" y="2286000"/>
+            <a:ext cx="4318000" cy="1905000"/>
+          </a:xfrm>
+          <a:prstGeom prst="roundRect">
+            <a:avLst>
+              <a:gd name="adj" fmla="val 0"/>
+            </a:avLst>
+          </a:prstGeom>
+          <a:solidFill>
+            <a:srgbClr val="C9302C">
+              <a:alpha val="8000"/>
+            </a:srgbClr>
+          </a:solidFill>
+          <a:ln w="25400" cmpd="sng" cap="flat">
+            <a:noFill/>
+            <a:prstDash val="solid"/>
+            <a:round/>
+          </a:ln>
+        </p:spPr>
+        <p:txBody>
+          <a:bodyPr anchor="ctr" rtlCol="false" anchorCtr="false" vert="horz" wrap="square" lIns="0" rIns="0" tIns="0" bIns="0"/>
+          <a:lstStyle/>
+          <a:p>
+            <a:pPr algn="ctr">
+              <a:defRPr/>
+            </a:pPr>
+            <a:endParaRPr/>
+          </a:p>
+        </p:txBody>
+      </p:sp>
+      <p:sp>
+        <p:nvSpPr>
+          <p:cNvPr name="AutoShape 8" id="8"/>
+          <p:cNvSpPr/>
+          <p:nvPr/>
+        </p:nvSpPr>
+        <p:spPr>
+          <a:xfrm rot="0" flipH="false" flipV="false">
+            <a:off x="7112000" y="2514600"/>
+            <a:ext cx="3810000" cy="304800"/>
+          </a:xfrm>
+          <a:prstGeom prst="rect">
+            <a:avLst/>
+          </a:prstGeom>
+          <a:noFill/>
+          <a:ln w="12700" cmpd="sng" cap="flat">
+            <a:noFill/>
+            <a:prstDash val="solid"/>
+            <a:round/>
+          </a:ln>
+        </p:spPr>
+        <p:txBody>
+          <a:bodyPr anchor="ctr" rtlCol="false" anchorCtr="false" vert="horz" wrap="square" lIns="0" rIns="0" tIns="0" bIns="0"/>
+          <a:lstStyle/>
+          <a:p>
+            <a:pPr algn="l" marL="0" indent="0">
+              <a:lnSpc>
+                <a:spcPct val="125000"/>
+              </a:lnSpc>
+              <a:defRPr/>
+            </a:pPr>
+            <a:r>
+              <a:rPr lang="en-US" b="true" i="false" strike="noStrike" u="none" sz="1500">
+                <a:solidFill>
+                  <a:srgbClr val="0D1326"/>
+                </a:solidFill>
+                <a:latin typeface="Noto Sans SC"/>
+                <a:ea typeface="Noto Sans SC"/>
+                <a:cs typeface="Noto Sans SC"/>
+                <a:sym typeface="Noto Sans SC"/>
+              </a:rPr>
+              <a:t>TabTin</a:t>
+            </a:r>
+            <a:endParaRPr lang="en-US" sz="1100"/>
+          </a:p>
+        </p:txBody>
+      </p:sp>
+      <p:sp>
+        <p:nvSpPr>
+          <p:cNvPr name="AutoShape 9" id="9"/>
+          <p:cNvSpPr/>
+          <p:nvPr/>
+        </p:nvSpPr>
+        <p:spPr>
+          <a:xfrm rot="0" flipH="false" flipV="false">
+            <a:off x="7112000" y="2921000"/>
+            <a:ext cx="3810000" cy="1143000"/>
+          </a:xfrm>
+          <a:prstGeom prst="rect">
+            <a:avLst/>
+          </a:prstGeom>
+          <a:noFill/>
+          <a:ln w="12700" cmpd="sng" cap="flat">
+            <a:noFill/>
+            <a:prstDash val="solid"/>
+            <a:round/>
+          </a:ln>
+        </p:spPr>
+        <p:txBody>
+          <a:bodyPr anchor="ctr" rtlCol="false" anchorCtr="false" vert="horz" wrap="square" lIns="0" rIns="0" tIns="0" bIns="0"/>
+          <a:lstStyle/>
+          <a:p>
+            <a:pPr algn="l" marL="0" indent="0">
+              <a:lnSpc>
+                <a:spcPct val="141666"/>
+              </a:lnSpc>
+              <a:defRPr/>
+            </a:pPr>
+            <a:r>
+              <a:rPr lang="en-US" b="false" i="false" strike="noStrike" u="none" sz="1300">
+                <a:solidFill>
+                  <a:srgbClr val="475569"/>
+                </a:solidFill>
+                <a:latin typeface="Noto Sans SC"/>
+                <a:ea typeface="Noto Sans SC"/>
+                <a:cs typeface="Noto Sans SC"/>
+                <a:sym typeface="Noto Sans SC"/>
+              </a:rPr>
+              <a:t>产品界的桥：</a:t>
+            </a:r>
+            <a:endParaRPr lang="en-US" sz="1100"/>
+          </a:p>
+          <a:p>
+            <a:pPr algn="l" marL="0" indent="0">
+              <a:lnSpc>
+                <a:spcPct val="141666"/>
+              </a:lnSpc>
+            </a:pPr>
+            <a:r>
+              <a:rPr lang="en-US" b="false" i="false" strike="noStrike" u="none" sz="1300">
+                <a:solidFill>
+                  <a:srgbClr val="475569"/>
+                </a:solidFill>
+                <a:latin typeface="Noto Sans SC"/>
+                <a:ea typeface="Noto Sans SC"/>
+                <a:cs typeface="Noto Sans SC"/>
+                <a:sym typeface="Noto Sans SC"/>
+              </a:rPr>
+              <a:t>保护人之间的</a:t>
+            </a:r>
+            <a:r>
+              <a:rPr lang="en-US" b="true" i="false" strike="noStrike" u="none" sz="1300">
+                <a:solidFill>
+                  <a:srgbClr val="0D1326"/>
+                </a:solidFill>
+                <a:latin typeface="Noto Sans SC"/>
+                <a:ea typeface="Noto Sans SC"/>
+                <a:cs typeface="Noto Sans SC"/>
+                <a:sym typeface="Noto Sans SC"/>
+              </a:rPr>
+              <a:t>工作上下文</a:t>
+            </a:r>
+            <a:r>
+              <a:rPr lang="en-US" b="false" i="false" strike="noStrike" u="none" sz="1300">
+                <a:solidFill>
+                  <a:srgbClr val="475569"/>
+                </a:solidFill>
+                <a:latin typeface="Noto Sans SC"/>
+                <a:ea typeface="Noto Sans SC"/>
+                <a:cs typeface="Noto Sans SC"/>
+                <a:sym typeface="Noto Sans SC"/>
+              </a:rPr>
+              <a:t>，不被交接丢掉</a:t>
+            </a:r>
+          </a:p>
+        </p:txBody>
+      </p:sp>
+      <p:sp>
+        <p:nvSpPr>
+          <p:cNvPr name="AutoShape 10" id="10"/>
+          <p:cNvSpPr/>
+          <p:nvPr/>
+        </p:nvSpPr>
+        <p:spPr>
+          <a:xfrm rot="0" flipH="false" flipV="false">
+            <a:off x="5588000" y="2984500"/>
+            <a:ext cx="1016000" cy="508000"/>
+          </a:xfrm>
+          <a:prstGeom prst="rect">
+            <a:avLst/>
+          </a:prstGeom>
+          <a:noFill/>
+          <a:ln w="12700" cmpd="sng" cap="flat">
+            <a:noFill/>
+            <a:prstDash val="solid"/>
+            <a:round/>
+          </a:ln>
+        </p:spPr>
+        <p:txBody>
+          <a:bodyPr anchor="ctr" rtlCol="false" anchorCtr="false" vert="horz" wrap="square" lIns="0" rIns="0" tIns="0" bIns="0"/>
+          <a:lstStyle/>
+          <a:p>
+            <a:pPr algn="ctr" marL="0" indent="0">
+              <a:lnSpc>
+                <a:spcPct val="125000"/>
+              </a:lnSpc>
+              <a:defRPr/>
+            </a:pPr>
+            <a:r>
+              <a:rPr lang="en-US" b="true" i="false" strike="noStrike" u="none" sz="2800">
+                <a:solidFill>
+                  <a:srgbClr val="94A3B8"/>
+                </a:solidFill>
+                <a:latin typeface="Noto Sans SC"/>
+                <a:ea typeface="Noto Sans SC"/>
+                <a:cs typeface="Noto Sans SC"/>
+                <a:sym typeface="Noto Sans SC"/>
+              </a:rPr>
+              <a:t>+</a:t>
+            </a:r>
+            <a:endParaRPr lang="en-US" sz="1100"/>
+          </a:p>
+        </p:txBody>
+      </p:sp>
+      <p:sp>
+        <p:nvSpPr>
+          <p:cNvPr name="AutoShape 11" id="11"/>
+          <p:cNvSpPr/>
+          <p:nvPr/>
+        </p:nvSpPr>
+        <p:spPr>
+          <a:xfrm rot="0" flipH="false" flipV="false">
+            <a:off x="2286000" y="4699000"/>
+            <a:ext cx="7620000" cy="889000"/>
+          </a:xfrm>
+          <a:prstGeom prst="roundRect">
+            <a:avLst>
+              <a:gd name="adj" fmla="val 0"/>
+            </a:avLst>
+          </a:prstGeom>
+          <a:solidFill>
+            <a:srgbClr val="FFFFFF">
+              <a:alpha val="100000"/>
+            </a:srgbClr>
+          </a:solidFill>
+          <a:ln w="12700" cmpd="sng" cap="flat">
+            <a:solidFill>
+              <a:srgbClr val="0D1326">
+                <a:alpha val="100000"/>
+              </a:srgbClr>
+            </a:solidFill>
+            <a:prstDash val="solid"/>
+            <a:round/>
+          </a:ln>
+        </p:spPr>
+        <p:txBody>
+          <a:bodyPr anchor="ctr" rtlCol="false" anchorCtr="false" vert="horz" wrap="square" lIns="0" rIns="0" tIns="0" bIns="0"/>
+          <a:lstStyle/>
+          <a:p>
+            <a:pPr algn="ctr">
+              <a:defRPr/>
+            </a:pPr>
+            <a:endParaRPr/>
+          </a:p>
+        </p:txBody>
+      </p:sp>
+      <p:sp>
+        <p:nvSpPr>
+          <p:cNvPr name="AutoShape 12" id="12"/>
+          <p:cNvSpPr/>
+          <p:nvPr/>
+        </p:nvSpPr>
+        <p:spPr>
+          <a:xfrm rot="0" flipH="false" flipV="false">
+            <a:off x="2540000" y="4851400"/>
+            <a:ext cx="7112000" cy="635000"/>
+          </a:xfrm>
+          <a:prstGeom prst="rect">
+            <a:avLst/>
+          </a:prstGeom>
+          <a:noFill/>
+          <a:ln w="12700" cmpd="sng" cap="flat">
+            <a:noFill/>
+            <a:prstDash val="solid"/>
+            <a:round/>
+          </a:ln>
+        </p:spPr>
+        <p:txBody>
+          <a:bodyPr anchor="ctr" rtlCol="false" anchorCtr="false" vert="horz" wrap="square" lIns="0" rIns="0" tIns="0" bIns="0"/>
+          <a:lstStyle/>
+          <a:p>
+            <a:pPr algn="ctr" marL="0" indent="0">
+              <a:lnSpc>
+                <a:spcPct val="125000"/>
+              </a:lnSpc>
+              <a:defRPr/>
+            </a:pPr>
+            <a:r>
+              <a:rPr lang="en-US" b="false" i="false" strike="noStrike" u="none" sz="1500">
+                <a:solidFill>
+                  <a:srgbClr val="0D1326"/>
+                </a:solidFill>
+                <a:latin typeface="Noto Sans SC"/>
+                <a:ea typeface="Noto Sans SC"/>
+                <a:cs typeface="Noto Sans SC"/>
+                <a:sym typeface="Noto Sans SC"/>
+              </a:rPr>
+              <a:t>共同的敌人：信息从一个工作主体传到另一个时，</a:t>
+            </a:r>
+            <a:endParaRPr lang="en-US" sz="1100"/>
+          </a:p>
+          <a:p>
+            <a:pPr algn="ctr" marL="0" indent="0">
+              <a:lnSpc>
+                <a:spcPct val="125000"/>
+              </a:lnSpc>
+            </a:pPr>
+            <a:r>
+              <a:rPr lang="en-US" b="false" i="false" strike="noStrike" u="none" sz="1500">
+                <a:solidFill>
+                  <a:srgbClr val="0D1326"/>
+                </a:solidFill>
+                <a:latin typeface="Noto Sans SC"/>
+                <a:ea typeface="Noto Sans SC"/>
+                <a:cs typeface="Noto Sans SC"/>
+                <a:sym typeface="Noto Sans SC"/>
+              </a:rPr>
+              <a:t>在"汇报 / 交接"这一步被压成了</a:t>
+            </a:r>
+            <a:r>
+              <a:rPr lang="en-US" b="true" i="false" strike="noStrike" u="none" sz="1500">
+                <a:solidFill>
+                  <a:srgbClr val="0D1326"/>
+                </a:solidFill>
+                <a:latin typeface="Noto Sans SC"/>
+                <a:ea typeface="Noto Sans SC"/>
+                <a:cs typeface="Noto Sans SC"/>
+                <a:sym typeface="Noto Sans SC"/>
+              </a:rPr>
+              <a:t>有损摘要</a:t>
+            </a:r>
+          </a:p>
+        </p:txBody>
+      </p:sp>
+    </p:spTree>
+  </p:cSld>
+  <p:clrMapOvr>
+    <a:masterClrMapping/>
+  </p:clrMapOvr>
+</p:sld>
+</file>
+
+<file path=ppt/slides/slide22.xml><?xml version="1.0" encoding="utf-8"?>
+<p:sld xmlns:p="http://schemas.openxmlformats.org/presentationml/2006/main" xmlns:a="http://schemas.openxmlformats.org/drawingml/2006/main">
+  <p:cSld>
+    <p:bg>
+      <p:bgPr>
+        <a:solidFill>
+          <a:srgbClr val="FFFFFF">
+            <a:alpha val="100000"/>
+          </a:srgbClr>
+        </a:solidFill>
+      </p:bgPr>
+    </p:bg>
+    <p:spTree>
+      <p:nvGrpSpPr>
+        <p:cNvPr id="1" name=""/>
+        <p:cNvGrpSpPr/>
+        <p:nvPr/>
+      </p:nvGrpSpPr>
+      <p:grpSpPr>
+        <a:xfrm>
+          <a:off x="0" y="0"/>
+          <a:ext cx="0" cy="0"/>
+          <a:chOff x="0" y="0"/>
+          <a:chExt cx="0" cy="0"/>
+        </a:xfrm>
+      </p:grpSpPr>
+      <p:sp>
+        <p:nvSpPr>
+          <p:cNvPr name="AutoShape 2" id="2"/>
+          <p:cNvSpPr/>
+          <p:nvPr/>
+        </p:nvSpPr>
+        <p:spPr>
+          <a:xfrm rot="0" flipH="false" flipV="false">
+            <a:off x="1016000" y="762000"/>
+            <a:ext cx="5080000" cy="254000"/>
+          </a:xfrm>
+          <a:prstGeom prst="rect">
+            <a:avLst/>
+          </a:prstGeom>
+          <a:noFill/>
+          <a:ln w="12700" cmpd="sng" cap="flat">
+            <a:noFill/>
+            <a:prstDash val="solid"/>
+            <a:round/>
+          </a:ln>
+        </p:spPr>
+        <p:txBody>
+          <a:bodyPr anchor="ctr" rtlCol="false" anchorCtr="false" vert="horz" wrap="square" lIns="0" rIns="0" tIns="0" bIns="0"/>
+          <a:lstStyle/>
+          <a:p>
+            <a:pPr algn="l" marL="0" indent="0">
+              <a:lnSpc>
+                <a:spcPct val="125000"/>
+              </a:lnSpc>
+              <a:defRPr/>
+            </a:pPr>
+            <a:r>
+              <a:rPr lang="en-US" b="false" i="false" strike="noStrike" u="none" sz="1100">
+                <a:solidFill>
+                  <a:srgbClr val="94A3B8"/>
+                </a:solidFill>
+                <a:latin typeface="Noto Sans SC"/>
+                <a:ea typeface="Noto Sans SC"/>
+                <a:cs typeface="Noto Sans SC"/>
+                <a:sym typeface="Noto Sans SC"/>
+              </a:rPr>
               <a:t>06 · 收尾</a:t>
             </a:r>
             <a:endParaRPr lang="en-US" sz="1100"/>
@@ -26921,7 +27830,7 @@
 </p:sld>
 </file>
 
-<file path=ppt/slides/slide22.xml><?xml version="1.0" encoding="utf-8"?>
+<file path=ppt/slides/slide23.xml><?xml version="1.0" encoding="utf-8"?>
 <p:sld xmlns:p="http://schemas.openxmlformats.org/presentationml/2006/main" xmlns:a="http://schemas.openxmlformats.org/drawingml/2006/main" xmlns:r="http://schemas.openxmlformats.org/officeDocument/2006/relationships">
   <p:cSld>
     <p:bg>

</xml_diff>